<commit_message>
Revised slides based on recording
</commit_message>
<xml_diff>
--- a/slides/CEP146_Rust_2026.pptx
+++ b/slides/CEP146_Rust_2026.pptx
@@ -19,7 +19,6 @@
     <p:sldId id="264" r:id="rId14"/>
     <p:sldId id="265" r:id="rId15"/>
     <p:sldId id="266" r:id="rId16"/>
-    <p:sldId id="267" r:id="rId17"/>
   </p:sldIdLst>
   <p:sldSz cy="6858000" cx="12191675"/>
   <p:notesSz cx="6858000" cy="9144000"/>
@@ -801,7 +800,7 @@
   <p:cSld>
     <p:spTree>
       <p:nvGrpSpPr>
-        <p:cNvPr id="213" name="Shape 213"/>
+        <p:cNvPr id="217" name="Shape 217"/>
         <p:cNvGrpSpPr/>
         <p:nvPr/>
       </p:nvGrpSpPr>
@@ -815,7 +814,7 @@
       </p:grpSpPr>
       <p:sp>
         <p:nvSpPr>
-          <p:cNvPr id="214" name="Google Shape;214;p4:notes"/>
+          <p:cNvPr id="218" name="Google Shape;218;p6:notes"/>
           <p:cNvSpPr txBox="1"/>
           <p:nvPr>
             <p:ph idx="1" type="body"/>
@@ -854,7 +853,7 @@
       </p:sp>
       <p:sp>
         <p:nvSpPr>
-          <p:cNvPr id="215" name="Google Shape;215;p4:notes"/>
+          <p:cNvPr id="219" name="Google Shape;219;p6:notes"/>
           <p:cNvSpPr/>
           <p:nvPr>
             <p:ph idx="2" type="sldImg"/>
@@ -900,7 +899,7 @@
   <p:cSld>
     <p:spTree>
       <p:nvGrpSpPr>
-        <p:cNvPr id="228" name="Shape 228"/>
+        <p:cNvPr id="234" name="Shape 234"/>
         <p:cNvGrpSpPr/>
         <p:nvPr/>
       </p:nvGrpSpPr>
@@ -914,7 +913,7 @@
       </p:grpSpPr>
       <p:sp>
         <p:nvSpPr>
-          <p:cNvPr id="229" name="Google Shape;229;p5:notes"/>
+          <p:cNvPr id="235" name="Google Shape;235;h1398c9f15236e7fa_1_0:notes"/>
           <p:cNvSpPr txBox="1"/>
           <p:nvPr>
             <p:ph idx="1" type="body"/>
@@ -953,7 +952,7 @@
       </p:sp>
       <p:sp>
         <p:nvSpPr>
-          <p:cNvPr id="230" name="Google Shape;230;p5:notes"/>
+          <p:cNvPr id="236" name="Google Shape;236;h1398c9f15236e7fa_1_0:notes"/>
           <p:cNvSpPr/>
           <p:nvPr>
             <p:ph idx="2" type="sldImg"/>
@@ -962,106 +961,7 @@
         <p:spPr>
           <a:xfrm>
             <a:off x="1143225" y="685800"/>
-            <a:ext cx="4572225" cy="3429000"/>
-          </a:xfrm>
-          <a:custGeom>
-            <a:rect b="b" l="l" r="r" t="t"/>
-            <a:pathLst>
-              <a:path extrusionOk="0" h="120000" w="120000">
-                <a:moveTo>
-                  <a:pt x="0" y="0"/>
-                </a:moveTo>
-                <a:lnTo>
-                  <a:pt x="120000" y="0"/>
-                </a:lnTo>
-                <a:lnTo>
-                  <a:pt x="120000" y="120000"/>
-                </a:lnTo>
-                <a:lnTo>
-                  <a:pt x="0" y="120000"/>
-                </a:lnTo>
-                <a:close/>
-              </a:path>
-            </a:pathLst>
-          </a:custGeom>
-        </p:spPr>
-      </p:sp>
-    </p:spTree>
-  </p:cSld>
-  <p:clrMapOvr>
-    <a:masterClrMapping/>
-  </p:clrMapOvr>
-</p:notes>
-</file>
-
-<file path=ppt/notesSlides/notesSlide12.xml><?xml version="1.0" encoding="utf-8"?>
-<p:notes xmlns:a="http://schemas.openxmlformats.org/drawingml/2006/main" xmlns:r="http://schemas.openxmlformats.org/officeDocument/2006/relationships" xmlns:mc="http://schemas.openxmlformats.org/markup-compatibility/2006" xmlns:mv="urn:schemas-microsoft-com:mac:vml" xmlns:p="http://schemas.openxmlformats.org/presentationml/2006/main" xmlns:c="http://schemas.openxmlformats.org/drawingml/2006/chart" xmlns:dgm="http://schemas.openxmlformats.org/drawingml/2006/diagram" xmlns:o="urn:schemas-microsoft-com:office:office" xmlns:v="urn:schemas-microsoft-com:vml" xmlns:pvml="urn:schemas-microsoft-com:office:powerpoint" xmlns:com="http://schemas.openxmlformats.org/drawingml/2006/compatibility" xmlns:p14="http://schemas.microsoft.com/office/powerpoint/2010/main" xmlns:p15="http://schemas.microsoft.com/office/powerpoint/2012/main" xmlns:ahyp="http://schemas.microsoft.com/office/drawing/2018/hyperlinkcolor" showMasterPhAnim="0" showMasterSp="0">
-  <p:cSld>
-    <p:spTree>
-      <p:nvGrpSpPr>
-        <p:cNvPr id="249" name="Shape 249"/>
-        <p:cNvGrpSpPr/>
-        <p:nvPr/>
-      </p:nvGrpSpPr>
-      <p:grpSpPr>
-        <a:xfrm>
-          <a:off x="0" y="0"/>
-          <a:ext cx="0" cy="0"/>
-          <a:chOff x="0" y="0"/>
-          <a:chExt cx="0" cy="0"/>
-        </a:xfrm>
-      </p:grpSpPr>
-      <p:sp>
-        <p:nvSpPr>
-          <p:cNvPr id="250" name="Google Shape;250;p6:notes"/>
-          <p:cNvSpPr txBox="1"/>
-          <p:nvPr>
-            <p:ph idx="1" type="body"/>
-          </p:nvPr>
-        </p:nvSpPr>
-        <p:spPr>
-          <a:xfrm>
-            <a:off x="685800" y="4343400"/>
-            <a:ext cx="5486400" cy="4114800"/>
-          </a:xfrm>
-          <a:prstGeom prst="rect">
-            <a:avLst/>
-          </a:prstGeom>
-        </p:spPr>
-        <p:txBody>
-          <a:bodyPr anchorCtr="0" anchor="t" bIns="91425" lIns="91425" spcFirstLastPara="1" rIns="91425" wrap="square" tIns="91425">
-            <a:noAutofit/>
-          </a:bodyPr>
-          <a:lstStyle/>
-          <a:p>
-            <a:pPr indent="0" lvl="0" marL="0" rtl="0" algn="l">
-              <a:spcBef>
-                <a:spcPts val="0"/>
-              </a:spcBef>
-              <a:spcAft>
-                <a:spcPts val="0"/>
-              </a:spcAft>
-              <a:buNone/>
-            </a:pPr>
-            <a:r>
-              <a:t/>
-            </a:r>
-            <a:endParaRPr/>
-          </a:p>
-        </p:txBody>
-      </p:sp>
-      <p:sp>
-        <p:nvSpPr>
-          <p:cNvPr id="251" name="Google Shape;251;p6:notes"/>
-          <p:cNvSpPr/>
-          <p:nvPr>
-            <p:ph idx="2" type="sldImg"/>
-          </p:nvPr>
-        </p:nvSpPr>
-        <p:spPr>
-          <a:xfrm>
-            <a:off x="1143225" y="685800"/>
-            <a:ext cx="4572225" cy="3429000"/>
+            <a:ext cx="4572300" cy="3429000"/>
           </a:xfrm>
           <a:custGeom>
             <a:rect b="b" l="l" r="r" t="t"/>
@@ -1805,7 +1705,7 @@
       </p:grpSpPr>
       <p:sp>
         <p:nvSpPr>
-          <p:cNvPr id="197" name="Google Shape;197;p3:notes"/>
+          <p:cNvPr id="197" name="Google Shape;197;p5:notes"/>
           <p:cNvSpPr txBox="1"/>
           <p:nvPr>
             <p:ph idx="1" type="body"/>
@@ -1844,7 +1744,7 @@
       </p:sp>
       <p:sp>
         <p:nvSpPr>
-          <p:cNvPr id="198" name="Google Shape;198;p3:notes"/>
+          <p:cNvPr id="198" name="Google Shape;198;p5:notes"/>
           <p:cNvSpPr/>
           <p:nvPr>
             <p:ph idx="2" type="sldImg"/>
@@ -11901,7 +11801,7 @@
   <p:cSld>
     <p:spTree>
       <p:nvGrpSpPr>
-        <p:cNvPr id="216" name="Shape 216"/>
+        <p:cNvPr id="220" name="Shape 220"/>
         <p:cNvGrpSpPr/>
         <p:nvPr/>
       </p:nvGrpSpPr>
@@ -11915,7 +11815,7 @@
       </p:grpSpPr>
       <p:sp>
         <p:nvSpPr>
-          <p:cNvPr id="217" name="Google Shape;217;p22"/>
+          <p:cNvPr id="221" name="Google Shape;221;p22"/>
           <p:cNvSpPr/>
           <p:nvPr/>
         </p:nvSpPr>
@@ -11973,7 +11873,7 @@
       </p:sp>
       <p:sp>
         <p:nvSpPr>
-          <p:cNvPr id="218" name="Google Shape;218;p22"/>
+          <p:cNvPr id="222" name="Google Shape;222;p22"/>
           <p:cNvSpPr/>
           <p:nvPr/>
         </p:nvSpPr>
@@ -12031,7 +11931,7 @@
       </p:sp>
       <p:sp>
         <p:nvSpPr>
-          <p:cNvPr id="219" name="Google Shape;219;p22"/>
+          <p:cNvPr id="223" name="Google Shape;223;p22"/>
           <p:cNvSpPr txBox="1"/>
           <p:nvPr/>
         </p:nvSpPr>
@@ -12081,14 +11981,14 @@
       </p:sp>
       <p:sp>
         <p:nvSpPr>
-          <p:cNvPr id="220" name="Google Shape;220;p22"/>
+          <p:cNvPr id="224" name="Google Shape;224;p22"/>
           <p:cNvSpPr txBox="1"/>
           <p:nvPr/>
         </p:nvSpPr>
         <p:spPr>
           <a:xfrm>
             <a:off x="621792" y="978408"/>
-            <a:ext cx="10972800" cy="731520"/>
+            <a:ext cx="10972800" cy="477300"/>
           </a:xfrm>
           <a:prstGeom prst="rect">
             <a:avLst/>
@@ -12123,7 +12023,47 @@
                 <a:cs typeface="Arial"/>
                 <a:sym typeface="Arial"/>
               </a:rPr>
-              <a:t>Why does memory safety matter?</a:t>
+              <a:t>Challenges and </a:t>
+            </a:r>
+            <a:r>
+              <a:rPr b="1" lang="en-US" sz="3100">
+                <a:solidFill>
+                  <a:srgbClr val="F6F7FA"/>
+                </a:solidFill>
+              </a:rPr>
+              <a:t>F</a:t>
+            </a:r>
+            <a:r>
+              <a:rPr b="1" i="0" lang="en-US" sz="3100" u="none" cap="none" strike="noStrike">
+                <a:solidFill>
+                  <a:srgbClr val="F6F7FA"/>
+                </a:solidFill>
+                <a:latin typeface="Arial"/>
+                <a:ea typeface="Arial"/>
+                <a:cs typeface="Arial"/>
+                <a:sym typeface="Arial"/>
+              </a:rPr>
+              <a:t>inal </a:t>
+            </a:r>
+            <a:r>
+              <a:rPr b="1" lang="en-US" sz="3100">
+                <a:solidFill>
+                  <a:srgbClr val="F6F7FA"/>
+                </a:solidFill>
+              </a:rPr>
+              <a:t>T</a:t>
+            </a:r>
+            <a:r>
+              <a:rPr b="1" i="0" lang="en-US" sz="3100" u="none" cap="none" strike="noStrike">
+                <a:solidFill>
+                  <a:srgbClr val="F6F7FA"/>
+                </a:solidFill>
+                <a:latin typeface="Arial"/>
+                <a:ea typeface="Arial"/>
+                <a:cs typeface="Arial"/>
+                <a:sym typeface="Arial"/>
+              </a:rPr>
+              <a:t>houghts</a:t>
             </a:r>
             <a:endParaRPr/>
           </a:p>
@@ -12131,7 +12071,7 @@
       </p:sp>
       <p:sp>
         <p:nvSpPr>
-          <p:cNvPr id="221" name="Google Shape;221;p22"/>
+          <p:cNvPr id="225" name="Google Shape;225;p22"/>
           <p:cNvSpPr txBox="1"/>
           <p:nvPr/>
         </p:nvSpPr>
@@ -12173,7 +12113,7 @@
                 <a:cs typeface="Arial"/>
                 <a:sym typeface="Arial"/>
               </a:rPr>
-              <a:t>04  /  RUST IN 2026</a:t>
+              <a:t>06  /  RUST IN 2026</a:t>
             </a:r>
             <a:endParaRPr/>
           </a:p>
@@ -12181,13 +12121,13 @@
       </p:sp>
       <p:sp>
         <p:nvSpPr>
-          <p:cNvPr id="222" name="Google Shape;222;p22"/>
+          <p:cNvPr id="226" name="Google Shape;226;p22"/>
           <p:cNvSpPr/>
           <p:nvPr/>
         </p:nvSpPr>
         <p:spPr>
           <a:xfrm>
-            <a:off x="758952" y="2157984"/>
+            <a:off x="758952" y="2103120"/>
             <a:ext cx="100584" cy="100584"/>
           </a:xfrm>
           <a:prstGeom prst="rect">
@@ -12239,13 +12179,13 @@
       </p:sp>
       <p:sp>
         <p:nvSpPr>
-          <p:cNvPr id="223" name="Google Shape;223;p22"/>
+          <p:cNvPr id="227" name="Google Shape;227;p22"/>
           <p:cNvSpPr txBox="1"/>
           <p:nvPr/>
         </p:nvSpPr>
         <p:spPr>
           <a:xfrm>
-            <a:off x="1042415" y="2048256"/>
+            <a:off x="1042415" y="1993392"/>
             <a:ext cx="10241280" cy="685800"/>
           </a:xfrm>
           <a:prstGeom prst="rect">
@@ -12272,7 +12212,7 @@
               <a:buNone/>
             </a:pPr>
             <a:r>
-              <a:rPr b="0" i="0" lang="en-US" sz="2100" u="none" cap="none" strike="noStrike">
+              <a:rPr b="0" i="0" lang="en-US" sz="2000" u="none" cap="none" strike="noStrike">
                 <a:solidFill>
                   <a:srgbClr val="F6F7FA"/>
                 </a:solidFill>
@@ -12281,7 +12221,7 @@
                 <a:cs typeface="Arial"/>
                 <a:sym typeface="Arial"/>
               </a:rPr>
-              <a:t>Memory mistakes can cause crashes and security problems</a:t>
+              <a:t>Rust can be difficult to learn, especially ownership rules</a:t>
             </a:r>
             <a:endParaRPr/>
           </a:p>
@@ -12289,13 +12229,13 @@
       </p:sp>
       <p:sp>
         <p:nvSpPr>
-          <p:cNvPr id="224" name="Google Shape;224;p22"/>
+          <p:cNvPr id="228" name="Google Shape;228;p22"/>
           <p:cNvSpPr/>
           <p:nvPr/>
         </p:nvSpPr>
         <p:spPr>
           <a:xfrm>
-            <a:off x="758952" y="3264408"/>
+            <a:off x="758952" y="3072384"/>
             <a:ext cx="100584" cy="100584"/>
           </a:xfrm>
           <a:prstGeom prst="rect">
@@ -12347,13 +12287,13 @@
       </p:sp>
       <p:sp>
         <p:nvSpPr>
-          <p:cNvPr id="225" name="Google Shape;225;p22"/>
+          <p:cNvPr id="229" name="Google Shape;229;p22"/>
           <p:cNvSpPr txBox="1"/>
           <p:nvPr/>
         </p:nvSpPr>
         <p:spPr>
           <a:xfrm>
-            <a:off x="1042415" y="3154680"/>
+            <a:off x="1042415" y="2962656"/>
             <a:ext cx="10241280" cy="685800"/>
           </a:xfrm>
           <a:prstGeom prst="rect">
@@ -12380,7 +12320,7 @@
               <a:buNone/>
             </a:pPr>
             <a:r>
-              <a:rPr b="0" i="0" lang="en-US" sz="2100" u="none" cap="none" strike="noStrike">
+              <a:rPr b="0" i="0" lang="en-US" sz="2000" u="none" cap="none" strike="noStrike">
                 <a:solidFill>
                   <a:srgbClr val="F6F7FA"/>
                 </a:solidFill>
@@ -12389,7 +12329,7 @@
                 <a:cs typeface="Arial"/>
                 <a:sym typeface="Arial"/>
               </a:rPr>
-              <a:t>Rust checks ownership and borrowing while code is compiled</a:t>
+              <a:t>Compiler checks can make development feel slower at first</a:t>
             </a:r>
             <a:endParaRPr/>
           </a:p>
@@ -12397,13 +12337,13 @@
       </p:sp>
       <p:sp>
         <p:nvSpPr>
-          <p:cNvPr id="226" name="Google Shape;226;p22"/>
+          <p:cNvPr id="230" name="Google Shape;230;p22"/>
           <p:cNvSpPr/>
           <p:nvPr/>
         </p:nvSpPr>
         <p:spPr>
           <a:xfrm>
-            <a:off x="758952" y="4407408"/>
+            <a:off x="758952" y="4050791"/>
             <a:ext cx="100584" cy="100584"/>
           </a:xfrm>
           <a:prstGeom prst="rect">
@@ -12455,13 +12395,13 @@
       </p:sp>
       <p:sp>
         <p:nvSpPr>
-          <p:cNvPr id="227" name="Google Shape;227;p22"/>
+          <p:cNvPr id="231" name="Google Shape;231;p22"/>
           <p:cNvSpPr txBox="1"/>
           <p:nvPr/>
         </p:nvSpPr>
         <p:spPr>
           <a:xfrm>
-            <a:off x="1042415" y="4297680"/>
+            <a:off x="1042415" y="3941063"/>
             <a:ext cx="10241280" cy="685800"/>
           </a:xfrm>
           <a:prstGeom prst="rect">
@@ -12488,7 +12428,7 @@
               <a:buNone/>
             </a:pPr>
             <a:r>
-              <a:rPr b="0" i="0" lang="en-US" sz="2100" u="none" cap="none" strike="noStrike">
+              <a:rPr b="0" i="0" lang="en-US" sz="2000" u="none" cap="none" strike="noStrike">
                 <a:solidFill>
                   <a:srgbClr val="F6F7FA"/>
                 </a:solidFill>
@@ -12497,53 +12437,28 @@
                 <a:cs typeface="Arial"/>
                 <a:sym typeface="Arial"/>
               </a:rPr>
-              <a:t>This helps catch some bugs before the program runs</a:t>
+              <a:t>It will not replace every C or C++ program</a:t>
             </a:r>
             <a:endParaRPr/>
           </a:p>
         </p:txBody>
       </p:sp>
-    </p:spTree>
-  </p:cSld>
-  <p:clrMapOvr>
-    <a:masterClrMapping/>
-  </p:clrMapOvr>
-</p:sld>
-</file>
-
-<file path=ppt/slides/slide11.xml><?xml version="1.0" encoding="utf-8"?>
-<p:sld xmlns:a="http://schemas.openxmlformats.org/drawingml/2006/main" xmlns:r="http://schemas.openxmlformats.org/officeDocument/2006/relationships" xmlns:mc="http://schemas.openxmlformats.org/markup-compatibility/2006" xmlns:mv="urn:schemas-microsoft-com:mac:vml" xmlns:p="http://schemas.openxmlformats.org/presentationml/2006/main" xmlns:c="http://schemas.openxmlformats.org/drawingml/2006/chart" xmlns:dgm="http://schemas.openxmlformats.org/drawingml/2006/diagram" xmlns:o="urn:schemas-microsoft-com:office:office" xmlns:v="urn:schemas-microsoft-com:vml" xmlns:pvml="urn:schemas-microsoft-com:office:powerpoint" xmlns:com="http://schemas.openxmlformats.org/drawingml/2006/compatibility" xmlns:p14="http://schemas.microsoft.com/office/powerpoint/2010/main" xmlns:p15="http://schemas.microsoft.com/office/powerpoint/2012/main" xmlns:ahyp="http://schemas.microsoft.com/office/drawing/2018/hyperlinkcolor">
-  <p:cSld>
-    <p:spTree>
-      <p:nvGrpSpPr>
-        <p:cNvPr id="231" name="Shape 231"/>
-        <p:cNvGrpSpPr/>
-        <p:nvPr/>
-      </p:nvGrpSpPr>
-      <p:grpSpPr>
-        <a:xfrm>
-          <a:off x="0" y="0"/>
-          <a:ext cx="0" cy="0"/>
-          <a:chOff x="0" y="0"/>
-          <a:chExt cx="0" cy="0"/>
-        </a:xfrm>
-      </p:grpSpPr>
-      <p:sp>
-        <p:nvSpPr>
-          <p:cNvPr id="232" name="Google Shape;232;p23"/>
+      <p:sp>
+        <p:nvSpPr>
+          <p:cNvPr id="232" name="Google Shape;232;p22"/>
           <p:cNvSpPr/>
           <p:nvPr/>
         </p:nvSpPr>
         <p:spPr>
           <a:xfrm>
-            <a:off x="0" y="0"/>
-            <a:ext cx="12191695" cy="6858000"/>
+            <a:off x="749808" y="5074920"/>
+            <a:ext cx="10698480" cy="868680"/>
           </a:xfrm>
           <a:prstGeom prst="rect">
             <a:avLst/>
           </a:prstGeom>
           <a:solidFill>
-            <a:srgbClr val="111B2B"/>
+            <a:srgbClr val="1D2B3F"/>
           </a:solidFill>
           <a:ln>
             <a:noFill/>
@@ -12588,20 +12503,95 @@
       </p:sp>
       <p:sp>
         <p:nvSpPr>
-          <p:cNvPr id="233" name="Google Shape;233;p23"/>
+          <p:cNvPr id="233" name="Google Shape;233;p22"/>
+          <p:cNvSpPr txBox="1"/>
+          <p:nvPr/>
+        </p:nvSpPr>
+        <p:spPr>
+          <a:xfrm>
+            <a:off x="1005840" y="5330952"/>
+            <a:ext cx="10241280" cy="411480"/>
+          </a:xfrm>
+          <a:prstGeom prst="rect">
+            <a:avLst/>
+          </a:prstGeom>
+          <a:noFill/>
+          <a:ln>
+            <a:noFill/>
+          </a:ln>
+        </p:spPr>
+        <p:txBody>
+          <a:bodyPr anchorCtr="0" anchor="t" bIns="0" lIns="0" spcFirstLastPara="1" rIns="0" wrap="square" tIns="0">
+            <a:spAutoFit/>
+          </a:bodyPr>
+          <a:lstStyle/>
+          <a:p>
+            <a:pPr indent="0" lvl="0" marL="0" marR="0" rtl="0" algn="l">
+              <a:spcBef>
+                <a:spcPts val="0"/>
+              </a:spcBef>
+              <a:spcAft>
+                <a:spcPts val="0"/>
+              </a:spcAft>
+              <a:buNone/>
+            </a:pPr>
+            <a:r>
+              <a:rPr b="1" i="0" lang="en-US" sz="2100" u="none" cap="none" strike="noStrike">
+                <a:solidFill>
+                  <a:srgbClr val="F6F7FA"/>
+                </a:solidFill>
+                <a:latin typeface="Arial"/>
+                <a:ea typeface="Arial"/>
+                <a:cs typeface="Arial"/>
+                <a:sym typeface="Arial"/>
+              </a:rPr>
+              <a:t>Rust is becoming a serious option for safer systems software.</a:t>
+            </a:r>
+            <a:endParaRPr/>
+          </a:p>
+        </p:txBody>
+      </p:sp>
+    </p:spTree>
+  </p:cSld>
+  <p:clrMapOvr>
+    <a:masterClrMapping/>
+  </p:clrMapOvr>
+</p:sld>
+</file>
+
+<file path=ppt/slides/slide11.xml><?xml version="1.0" encoding="utf-8"?>
+<p:sld xmlns:a="http://schemas.openxmlformats.org/drawingml/2006/main" xmlns:r="http://schemas.openxmlformats.org/officeDocument/2006/relationships" xmlns:mc="http://schemas.openxmlformats.org/markup-compatibility/2006" xmlns:mv="urn:schemas-microsoft-com:mac:vml" xmlns:p="http://schemas.openxmlformats.org/presentationml/2006/main" xmlns:c="http://schemas.openxmlformats.org/drawingml/2006/chart" xmlns:dgm="http://schemas.openxmlformats.org/drawingml/2006/diagram" xmlns:o="urn:schemas-microsoft-com:office:office" xmlns:v="urn:schemas-microsoft-com:vml" xmlns:pvml="urn:schemas-microsoft-com:office:powerpoint" xmlns:com="http://schemas.openxmlformats.org/drawingml/2006/compatibility" xmlns:p14="http://schemas.microsoft.com/office/powerpoint/2010/main" xmlns:p15="http://schemas.microsoft.com/office/powerpoint/2012/main" xmlns:ahyp="http://schemas.microsoft.com/office/drawing/2018/hyperlinkcolor">
+  <p:cSld>
+    <p:spTree>
+      <p:nvGrpSpPr>
+        <p:cNvPr id="237" name="Shape 237"/>
+        <p:cNvGrpSpPr/>
+        <p:nvPr/>
+      </p:nvGrpSpPr>
+      <p:grpSpPr>
+        <a:xfrm>
+          <a:off x="0" y="0"/>
+          <a:ext cx="0" cy="0"/>
+          <a:chOff x="0" y="0"/>
+          <a:chExt cx="0" cy="0"/>
+        </a:xfrm>
+      </p:grpSpPr>
+      <p:sp>
+        <p:nvSpPr>
+          <p:cNvPr id="238" name="Google Shape;238;p23"/>
           <p:cNvSpPr/>
           <p:nvPr/>
         </p:nvSpPr>
         <p:spPr>
           <a:xfrm>
-            <a:off x="411480" y="393192"/>
-            <a:ext cx="73152" cy="429768"/>
+            <a:off x="0" y="0"/>
+            <a:ext cx="12191700" cy="6858000"/>
           </a:xfrm>
           <a:prstGeom prst="rect">
             <a:avLst/>
           </a:prstGeom>
           <a:solidFill>
-            <a:srgbClr val="F08443"/>
+            <a:srgbClr val="111B2B"/>
           </a:solidFill>
           <a:ln>
             <a:noFill/>
@@ -12609,7 +12599,7 @@
           <a:effectLst>
             <a:outerShdw blurRad="40000" rotWithShape="0" dir="5400000" dist="23000">
               <a:srgbClr val="000000">
-                <a:alpha val="34902"/>
+                <a:alpha val="34900"/>
               </a:srgbClr>
             </a:outerShdw>
           </a:effectLst>
@@ -12646,14 +12636,72 @@
       </p:sp>
       <p:sp>
         <p:nvSpPr>
-          <p:cNvPr id="234" name="Google Shape;234;p23"/>
+          <p:cNvPr id="239" name="Google Shape;239;p23"/>
+          <p:cNvSpPr/>
+          <p:nvPr/>
+        </p:nvSpPr>
+        <p:spPr>
+          <a:xfrm>
+            <a:off x="411480" y="393192"/>
+            <a:ext cx="73200" cy="429900"/>
+          </a:xfrm>
+          <a:prstGeom prst="rect">
+            <a:avLst/>
+          </a:prstGeom>
+          <a:solidFill>
+            <a:srgbClr val="F08443"/>
+          </a:solidFill>
+          <a:ln>
+            <a:noFill/>
+          </a:ln>
+          <a:effectLst>
+            <a:outerShdw blurRad="40000" rotWithShape="0" dir="5400000" dist="23000">
+              <a:srgbClr val="000000">
+                <a:alpha val="34900"/>
+              </a:srgbClr>
+            </a:outerShdw>
+          </a:effectLst>
+        </p:spPr>
+        <p:txBody>
+          <a:bodyPr anchorCtr="0" anchor="ctr" bIns="45700" lIns="91425" spcFirstLastPara="1" rIns="91425" wrap="square" tIns="45700">
+            <a:noAutofit/>
+          </a:bodyPr>
+          <a:lstStyle/>
+          <a:p>
+            <a:pPr indent="0" lvl="0" marL="0" marR="0" rtl="0" algn="ctr">
+              <a:spcBef>
+                <a:spcPts val="0"/>
+              </a:spcBef>
+              <a:spcAft>
+                <a:spcPts val="0"/>
+              </a:spcAft>
+              <a:buNone/>
+            </a:pPr>
+            <a:r>
+              <a:t/>
+            </a:r>
+            <a:endParaRPr b="0" i="0" sz="1800" u="none" cap="none" strike="noStrike">
+              <a:solidFill>
+                <a:schemeClr val="dk1"/>
+              </a:solidFill>
+              <a:latin typeface="Calibri"/>
+              <a:ea typeface="Calibri"/>
+              <a:cs typeface="Calibri"/>
+              <a:sym typeface="Calibri"/>
+            </a:endParaRPr>
+          </a:p>
+        </p:txBody>
+      </p:sp>
+      <p:sp>
+        <p:nvSpPr>
+          <p:cNvPr id="240" name="Google Shape;240;p23"/>
           <p:cNvSpPr txBox="1"/>
           <p:nvPr/>
         </p:nvSpPr>
         <p:spPr>
           <a:xfrm>
             <a:off x="612648" y="411480"/>
-            <a:ext cx="7315200" cy="274320"/>
+            <a:ext cx="7315200" cy="169200"/>
           </a:xfrm>
           <a:prstGeom prst="rect">
             <a:avLst/>
@@ -12696,14 +12744,14 @@
       </p:sp>
       <p:sp>
         <p:nvSpPr>
-          <p:cNvPr id="235" name="Google Shape;235;p23"/>
+          <p:cNvPr id="241" name="Google Shape;241;p23"/>
           <p:cNvSpPr txBox="1"/>
           <p:nvPr/>
         </p:nvSpPr>
         <p:spPr>
           <a:xfrm>
-            <a:off x="621792" y="978408"/>
-            <a:ext cx="10972800" cy="731520"/>
+            <a:off x="609442" y="2639108"/>
+            <a:ext cx="10972800" cy="477300"/>
           </a:xfrm>
           <a:prstGeom prst="rect">
             <a:avLst/>
@@ -12719,7 +12767,7 @@
           </a:bodyPr>
           <a:lstStyle/>
           <a:p>
-            <a:pPr indent="0" lvl="0" marL="0" marR="0" rtl="0" algn="l">
+            <a:pPr indent="0" lvl="0" marL="0" marR="0" rtl="0" algn="ctr">
               <a:spcBef>
                 <a:spcPts val="0"/>
               </a:spcBef>
@@ -12729,16 +12777,12 @@
               <a:buNone/>
             </a:pPr>
             <a:r>
-              <a:rPr b="1" i="0" lang="en-US" sz="3100" u="none" cap="none" strike="noStrike">
+              <a:rPr b="1" lang="en-US" sz="3100">
                 <a:solidFill>
                   <a:srgbClr val="F6F7FA"/>
                 </a:solidFill>
-                <a:latin typeface="Arial"/>
-                <a:ea typeface="Arial"/>
-                <a:cs typeface="Arial"/>
-                <a:sym typeface="Arial"/>
               </a:rPr>
-              <a:t>Where is Rust being used?</a:t>
+              <a:t>The End</a:t>
             </a:r>
             <a:endParaRPr/>
           </a:p>
@@ -12746,14 +12790,14 @@
       </p:sp>
       <p:sp>
         <p:nvSpPr>
-          <p:cNvPr id="236" name="Google Shape;236;p23"/>
+          <p:cNvPr id="242" name="Google Shape;242;p23"/>
           <p:cNvSpPr txBox="1"/>
           <p:nvPr/>
         </p:nvSpPr>
         <p:spPr>
           <a:xfrm>
             <a:off x="9875520" y="6446520"/>
-            <a:ext cx="1828800" cy="182880"/>
+            <a:ext cx="1828800" cy="138600"/>
           </a:xfrm>
           <a:prstGeom prst="rect">
             <a:avLst/>
@@ -12788,1362 +12832,7 @@
                 <a:cs typeface="Arial"/>
                 <a:sym typeface="Arial"/>
               </a:rPr>
-              <a:t>05  /  RUST IN 2026</a:t>
-            </a:r>
-            <a:endParaRPr/>
-          </a:p>
-        </p:txBody>
-      </p:sp>
-      <p:sp>
-        <p:nvSpPr>
-          <p:cNvPr id="237" name="Google Shape;237;p23"/>
-          <p:cNvSpPr/>
-          <p:nvPr/>
-        </p:nvSpPr>
-        <p:spPr>
-          <a:xfrm>
-            <a:off x="749808" y="1938528"/>
-            <a:ext cx="2514600" cy="731520"/>
-          </a:xfrm>
-          <a:prstGeom prst="rect">
-            <a:avLst/>
-          </a:prstGeom>
-          <a:solidFill>
-            <a:srgbClr val="1D2B3F"/>
-          </a:solidFill>
-          <a:ln>
-            <a:noFill/>
-          </a:ln>
-          <a:effectLst>
-            <a:outerShdw blurRad="40000" rotWithShape="0" dir="5400000" dist="23000">
-              <a:srgbClr val="000000">
-                <a:alpha val="34902"/>
-              </a:srgbClr>
-            </a:outerShdw>
-          </a:effectLst>
-        </p:spPr>
-        <p:txBody>
-          <a:bodyPr anchorCtr="0" anchor="ctr" bIns="45700" lIns="91425" spcFirstLastPara="1" rIns="91425" wrap="square" tIns="45700">
-            <a:noAutofit/>
-          </a:bodyPr>
-          <a:lstStyle/>
-          <a:p>
-            <a:pPr indent="0" lvl="0" marL="0" marR="0" rtl="0" algn="ctr">
-              <a:spcBef>
-                <a:spcPts val="0"/>
-              </a:spcBef>
-              <a:spcAft>
-                <a:spcPts val="0"/>
-              </a:spcAft>
-              <a:buNone/>
-            </a:pPr>
-            <a:r>
-              <a:t/>
-            </a:r>
-            <a:endParaRPr b="0" i="0" sz="1800" u="none" cap="none" strike="noStrike">
-              <a:solidFill>
-                <a:schemeClr val="dk1"/>
-              </a:solidFill>
-              <a:latin typeface="Calibri"/>
-              <a:ea typeface="Calibri"/>
-              <a:cs typeface="Calibri"/>
-              <a:sym typeface="Calibri"/>
-            </a:endParaRPr>
-          </a:p>
-        </p:txBody>
-      </p:sp>
-      <p:sp>
-        <p:nvSpPr>
-          <p:cNvPr id="238" name="Google Shape;238;p23"/>
-          <p:cNvSpPr txBox="1"/>
-          <p:nvPr/>
-        </p:nvSpPr>
-        <p:spPr>
-          <a:xfrm>
-            <a:off x="950976" y="2093976"/>
-            <a:ext cx="2194560" cy="393192"/>
-          </a:xfrm>
-          <a:prstGeom prst="rect">
-            <a:avLst/>
-          </a:prstGeom>
-          <a:noFill/>
-          <a:ln>
-            <a:noFill/>
-          </a:ln>
-        </p:spPr>
-        <p:txBody>
-          <a:bodyPr anchorCtr="0" anchor="t" bIns="0" lIns="0" spcFirstLastPara="1" rIns="0" wrap="square" tIns="0">
-            <a:spAutoFit/>
-          </a:bodyPr>
-          <a:lstStyle/>
-          <a:p>
-            <a:pPr indent="0" lvl="0" marL="0" marR="0" rtl="0" algn="l">
-              <a:spcBef>
-                <a:spcPts val="0"/>
-              </a:spcBef>
-              <a:spcAft>
-                <a:spcPts val="0"/>
-              </a:spcAft>
-              <a:buNone/>
-            </a:pPr>
-            <a:r>
-              <a:rPr b="1" i="0" lang="en-US" sz="1900" u="none" cap="none" strike="noStrike">
-                <a:solidFill>
-                  <a:srgbClr val="F08443"/>
-                </a:solidFill>
-                <a:latin typeface="Arial"/>
-                <a:ea typeface="Arial"/>
-                <a:cs typeface="Arial"/>
-                <a:sym typeface="Arial"/>
-              </a:rPr>
-              <a:t>Linux</a:t>
-            </a:r>
-            <a:endParaRPr/>
-          </a:p>
-        </p:txBody>
-      </p:sp>
-      <p:sp>
-        <p:nvSpPr>
-          <p:cNvPr id="239" name="Google Shape;239;p23"/>
-          <p:cNvSpPr txBox="1"/>
-          <p:nvPr/>
-        </p:nvSpPr>
-        <p:spPr>
-          <a:xfrm>
-            <a:off x="3547872" y="2057400"/>
-            <a:ext cx="7863840" cy="594360"/>
-          </a:xfrm>
-          <a:prstGeom prst="rect">
-            <a:avLst/>
-          </a:prstGeom>
-          <a:noFill/>
-          <a:ln>
-            <a:noFill/>
-          </a:ln>
-        </p:spPr>
-        <p:txBody>
-          <a:bodyPr anchorCtr="0" anchor="t" bIns="0" lIns="0" spcFirstLastPara="1" rIns="0" wrap="square" tIns="0">
-            <a:spAutoFit/>
-          </a:bodyPr>
-          <a:lstStyle/>
-          <a:p>
-            <a:pPr indent="0" lvl="0" marL="0" marR="0" rtl="0" algn="l">
-              <a:spcBef>
-                <a:spcPts val="0"/>
-              </a:spcBef>
-              <a:spcAft>
-                <a:spcPts val="0"/>
-              </a:spcAft>
-              <a:buNone/>
-            </a:pPr>
-            <a:r>
-              <a:rPr b="0" i="0" lang="en-US" sz="1900" u="none" cap="none" strike="noStrike">
-                <a:solidFill>
-                  <a:srgbClr val="F6F7FA"/>
-                </a:solidFill>
-                <a:latin typeface="Arial"/>
-                <a:ea typeface="Arial"/>
-                <a:cs typeface="Arial"/>
-                <a:sym typeface="Arial"/>
-              </a:rPr>
-              <a:t>Developers can write some kernel components in Rust.</a:t>
-            </a:r>
-            <a:endParaRPr/>
-          </a:p>
-        </p:txBody>
-      </p:sp>
-      <p:sp>
-        <p:nvSpPr>
-          <p:cNvPr id="240" name="Google Shape;240;p23"/>
-          <p:cNvSpPr/>
-          <p:nvPr/>
-        </p:nvSpPr>
-        <p:spPr>
-          <a:xfrm>
-            <a:off x="749808" y="2962656"/>
-            <a:ext cx="2514600" cy="731520"/>
-          </a:xfrm>
-          <a:prstGeom prst="rect">
-            <a:avLst/>
-          </a:prstGeom>
-          <a:solidFill>
-            <a:srgbClr val="1D2B3F"/>
-          </a:solidFill>
-          <a:ln>
-            <a:noFill/>
-          </a:ln>
-          <a:effectLst>
-            <a:outerShdw blurRad="40000" rotWithShape="0" dir="5400000" dist="23000">
-              <a:srgbClr val="000000">
-                <a:alpha val="34902"/>
-              </a:srgbClr>
-            </a:outerShdw>
-          </a:effectLst>
-        </p:spPr>
-        <p:txBody>
-          <a:bodyPr anchorCtr="0" anchor="ctr" bIns="45700" lIns="91425" spcFirstLastPara="1" rIns="91425" wrap="square" tIns="45700">
-            <a:noAutofit/>
-          </a:bodyPr>
-          <a:lstStyle/>
-          <a:p>
-            <a:pPr indent="0" lvl="0" marL="0" marR="0" rtl="0" algn="ctr">
-              <a:spcBef>
-                <a:spcPts val="0"/>
-              </a:spcBef>
-              <a:spcAft>
-                <a:spcPts val="0"/>
-              </a:spcAft>
-              <a:buNone/>
-            </a:pPr>
-            <a:r>
-              <a:t/>
-            </a:r>
-            <a:endParaRPr b="0" i="0" sz="1800" u="none" cap="none" strike="noStrike">
-              <a:solidFill>
-                <a:schemeClr val="dk1"/>
-              </a:solidFill>
-              <a:latin typeface="Calibri"/>
-              <a:ea typeface="Calibri"/>
-              <a:cs typeface="Calibri"/>
-              <a:sym typeface="Calibri"/>
-            </a:endParaRPr>
-          </a:p>
-        </p:txBody>
-      </p:sp>
-      <p:sp>
-        <p:nvSpPr>
-          <p:cNvPr id="241" name="Google Shape;241;p23"/>
-          <p:cNvSpPr txBox="1"/>
-          <p:nvPr/>
-        </p:nvSpPr>
-        <p:spPr>
-          <a:xfrm>
-            <a:off x="950976" y="3118104"/>
-            <a:ext cx="2194560" cy="393192"/>
-          </a:xfrm>
-          <a:prstGeom prst="rect">
-            <a:avLst/>
-          </a:prstGeom>
-          <a:noFill/>
-          <a:ln>
-            <a:noFill/>
-          </a:ln>
-        </p:spPr>
-        <p:txBody>
-          <a:bodyPr anchorCtr="0" anchor="t" bIns="0" lIns="0" spcFirstLastPara="1" rIns="0" wrap="square" tIns="0">
-            <a:spAutoFit/>
-          </a:bodyPr>
-          <a:lstStyle/>
-          <a:p>
-            <a:pPr indent="0" lvl="0" marL="0" marR="0" rtl="0" algn="l">
-              <a:spcBef>
-                <a:spcPts val="0"/>
-              </a:spcBef>
-              <a:spcAft>
-                <a:spcPts val="0"/>
-              </a:spcAft>
-              <a:buNone/>
-            </a:pPr>
-            <a:r>
-              <a:rPr b="1" i="0" lang="en-US" sz="1900" u="none" cap="none" strike="noStrike">
-                <a:solidFill>
-                  <a:srgbClr val="F08443"/>
-                </a:solidFill>
-                <a:latin typeface="Arial"/>
-                <a:ea typeface="Arial"/>
-                <a:cs typeface="Arial"/>
-                <a:sym typeface="Arial"/>
-              </a:rPr>
-              <a:t>Google / Android</a:t>
-            </a:r>
-            <a:endParaRPr/>
-          </a:p>
-        </p:txBody>
-      </p:sp>
-      <p:sp>
-        <p:nvSpPr>
-          <p:cNvPr id="242" name="Google Shape;242;p23"/>
-          <p:cNvSpPr txBox="1"/>
-          <p:nvPr/>
-        </p:nvSpPr>
-        <p:spPr>
-          <a:xfrm>
-            <a:off x="3547872" y="3081528"/>
-            <a:ext cx="7863840" cy="594360"/>
-          </a:xfrm>
-          <a:prstGeom prst="rect">
-            <a:avLst/>
-          </a:prstGeom>
-          <a:noFill/>
-          <a:ln>
-            <a:noFill/>
-          </a:ln>
-        </p:spPr>
-        <p:txBody>
-          <a:bodyPr anchorCtr="0" anchor="t" bIns="0" lIns="0" spcFirstLastPara="1" rIns="0" wrap="square" tIns="0">
-            <a:spAutoFit/>
-          </a:bodyPr>
-          <a:lstStyle/>
-          <a:p>
-            <a:pPr indent="0" lvl="0" marL="0" marR="0" rtl="0" algn="l">
-              <a:spcBef>
-                <a:spcPts val="0"/>
-              </a:spcBef>
-              <a:spcAft>
-                <a:spcPts val="0"/>
-              </a:spcAft>
-              <a:buNone/>
-            </a:pPr>
-            <a:r>
-              <a:rPr b="0" i="0" lang="en-US" sz="1900" u="none" cap="none" strike="noStrike">
-                <a:solidFill>
-                  <a:srgbClr val="F6F7FA"/>
-                </a:solidFill>
-                <a:latin typeface="Arial"/>
-                <a:ea typeface="Arial"/>
-                <a:cs typeface="Arial"/>
-                <a:sym typeface="Arial"/>
-              </a:rPr>
-              <a:t>Rust is used in security-sensitive Android code.</a:t>
-            </a:r>
-            <a:endParaRPr/>
-          </a:p>
-        </p:txBody>
-      </p:sp>
-      <p:sp>
-        <p:nvSpPr>
-          <p:cNvPr id="243" name="Google Shape;243;p23"/>
-          <p:cNvSpPr/>
-          <p:nvPr/>
-        </p:nvSpPr>
-        <p:spPr>
-          <a:xfrm>
-            <a:off x="749808" y="3986784"/>
-            <a:ext cx="2514600" cy="731520"/>
-          </a:xfrm>
-          <a:prstGeom prst="rect">
-            <a:avLst/>
-          </a:prstGeom>
-          <a:solidFill>
-            <a:srgbClr val="1D2B3F"/>
-          </a:solidFill>
-          <a:ln>
-            <a:noFill/>
-          </a:ln>
-          <a:effectLst>
-            <a:outerShdw blurRad="40000" rotWithShape="0" dir="5400000" dist="23000">
-              <a:srgbClr val="000000">
-                <a:alpha val="34902"/>
-              </a:srgbClr>
-            </a:outerShdw>
-          </a:effectLst>
-        </p:spPr>
-        <p:txBody>
-          <a:bodyPr anchorCtr="0" anchor="ctr" bIns="45700" lIns="91425" spcFirstLastPara="1" rIns="91425" wrap="square" tIns="45700">
-            <a:noAutofit/>
-          </a:bodyPr>
-          <a:lstStyle/>
-          <a:p>
-            <a:pPr indent="0" lvl="0" marL="0" marR="0" rtl="0" algn="ctr">
-              <a:spcBef>
-                <a:spcPts val="0"/>
-              </a:spcBef>
-              <a:spcAft>
-                <a:spcPts val="0"/>
-              </a:spcAft>
-              <a:buNone/>
-            </a:pPr>
-            <a:r>
-              <a:t/>
-            </a:r>
-            <a:endParaRPr b="0" i="0" sz="1800" u="none" cap="none" strike="noStrike">
-              <a:solidFill>
-                <a:schemeClr val="dk1"/>
-              </a:solidFill>
-              <a:latin typeface="Calibri"/>
-              <a:ea typeface="Calibri"/>
-              <a:cs typeface="Calibri"/>
-              <a:sym typeface="Calibri"/>
-            </a:endParaRPr>
-          </a:p>
-        </p:txBody>
-      </p:sp>
-      <p:sp>
-        <p:nvSpPr>
-          <p:cNvPr id="244" name="Google Shape;244;p23"/>
-          <p:cNvSpPr txBox="1"/>
-          <p:nvPr/>
-        </p:nvSpPr>
-        <p:spPr>
-          <a:xfrm>
-            <a:off x="950976" y="4142232"/>
-            <a:ext cx="2194560" cy="393192"/>
-          </a:xfrm>
-          <a:prstGeom prst="rect">
-            <a:avLst/>
-          </a:prstGeom>
-          <a:noFill/>
-          <a:ln>
-            <a:noFill/>
-          </a:ln>
-        </p:spPr>
-        <p:txBody>
-          <a:bodyPr anchorCtr="0" anchor="t" bIns="0" lIns="0" spcFirstLastPara="1" rIns="0" wrap="square" tIns="0">
-            <a:spAutoFit/>
-          </a:bodyPr>
-          <a:lstStyle/>
-          <a:p>
-            <a:pPr indent="0" lvl="0" marL="0" marR="0" rtl="0" algn="l">
-              <a:spcBef>
-                <a:spcPts val="0"/>
-              </a:spcBef>
-              <a:spcAft>
-                <a:spcPts val="0"/>
-              </a:spcAft>
-              <a:buNone/>
-            </a:pPr>
-            <a:r>
-              <a:rPr b="1" i="0" lang="en-US" sz="1900" u="none" cap="none" strike="noStrike">
-                <a:solidFill>
-                  <a:srgbClr val="F08443"/>
-                </a:solidFill>
-                <a:latin typeface="Arial"/>
-                <a:ea typeface="Arial"/>
-                <a:cs typeface="Arial"/>
-                <a:sym typeface="Arial"/>
-              </a:rPr>
-              <a:t>Microsoft</a:t>
-            </a:r>
-            <a:endParaRPr/>
-          </a:p>
-        </p:txBody>
-      </p:sp>
-      <p:sp>
-        <p:nvSpPr>
-          <p:cNvPr id="245" name="Google Shape;245;p23"/>
-          <p:cNvSpPr txBox="1"/>
-          <p:nvPr/>
-        </p:nvSpPr>
-        <p:spPr>
-          <a:xfrm>
-            <a:off x="3547872" y="4105656"/>
-            <a:ext cx="7863840" cy="594360"/>
-          </a:xfrm>
-          <a:prstGeom prst="rect">
-            <a:avLst/>
-          </a:prstGeom>
-          <a:noFill/>
-          <a:ln>
-            <a:noFill/>
-          </a:ln>
-        </p:spPr>
-        <p:txBody>
-          <a:bodyPr anchorCtr="0" anchor="t" bIns="0" lIns="0" spcFirstLastPara="1" rIns="0" wrap="square" tIns="0">
-            <a:spAutoFit/>
-          </a:bodyPr>
-          <a:lstStyle/>
-          <a:p>
-            <a:pPr indent="0" lvl="0" marL="0" marR="0" rtl="0" algn="l">
-              <a:spcBef>
-                <a:spcPts val="0"/>
-              </a:spcBef>
-              <a:spcAft>
-                <a:spcPts val="0"/>
-              </a:spcAft>
-              <a:buNone/>
-            </a:pPr>
-            <a:r>
-              <a:rPr b="0" i="0" lang="en-US" sz="1900" u="none" cap="none" strike="noStrike">
-                <a:solidFill>
-                  <a:srgbClr val="F6F7FA"/>
-                </a:solidFill>
-                <a:latin typeface="Arial"/>
-                <a:ea typeface="Arial"/>
-                <a:cs typeface="Arial"/>
-                <a:sym typeface="Arial"/>
-              </a:rPr>
-              <a:t>Rust is being explored and used in some systems work.</a:t>
-            </a:r>
-            <a:endParaRPr/>
-          </a:p>
-        </p:txBody>
-      </p:sp>
-      <p:sp>
-        <p:nvSpPr>
-          <p:cNvPr id="246" name="Google Shape;246;p23"/>
-          <p:cNvSpPr/>
-          <p:nvPr/>
-        </p:nvSpPr>
-        <p:spPr>
-          <a:xfrm>
-            <a:off x="749808" y="5010912"/>
-            <a:ext cx="2514600" cy="731520"/>
-          </a:xfrm>
-          <a:prstGeom prst="rect">
-            <a:avLst/>
-          </a:prstGeom>
-          <a:solidFill>
-            <a:srgbClr val="1D2B3F"/>
-          </a:solidFill>
-          <a:ln>
-            <a:noFill/>
-          </a:ln>
-          <a:effectLst>
-            <a:outerShdw blurRad="40000" rotWithShape="0" dir="5400000" dist="23000">
-              <a:srgbClr val="000000">
-                <a:alpha val="34902"/>
-              </a:srgbClr>
-            </a:outerShdw>
-          </a:effectLst>
-        </p:spPr>
-        <p:txBody>
-          <a:bodyPr anchorCtr="0" anchor="ctr" bIns="45700" lIns="91425" spcFirstLastPara="1" rIns="91425" wrap="square" tIns="45700">
-            <a:noAutofit/>
-          </a:bodyPr>
-          <a:lstStyle/>
-          <a:p>
-            <a:pPr indent="0" lvl="0" marL="0" marR="0" rtl="0" algn="ctr">
-              <a:spcBef>
-                <a:spcPts val="0"/>
-              </a:spcBef>
-              <a:spcAft>
-                <a:spcPts val="0"/>
-              </a:spcAft>
-              <a:buNone/>
-            </a:pPr>
-            <a:r>
-              <a:t/>
-            </a:r>
-            <a:endParaRPr b="0" i="0" sz="1800" u="none" cap="none" strike="noStrike">
-              <a:solidFill>
-                <a:schemeClr val="dk1"/>
-              </a:solidFill>
-              <a:latin typeface="Calibri"/>
-              <a:ea typeface="Calibri"/>
-              <a:cs typeface="Calibri"/>
-              <a:sym typeface="Calibri"/>
-            </a:endParaRPr>
-          </a:p>
-        </p:txBody>
-      </p:sp>
-      <p:sp>
-        <p:nvSpPr>
-          <p:cNvPr id="247" name="Google Shape;247;p23"/>
-          <p:cNvSpPr txBox="1"/>
-          <p:nvPr/>
-        </p:nvSpPr>
-        <p:spPr>
-          <a:xfrm>
-            <a:off x="950976" y="5166360"/>
-            <a:ext cx="2194560" cy="393192"/>
-          </a:xfrm>
-          <a:prstGeom prst="rect">
-            <a:avLst/>
-          </a:prstGeom>
-          <a:noFill/>
-          <a:ln>
-            <a:noFill/>
-          </a:ln>
-        </p:spPr>
-        <p:txBody>
-          <a:bodyPr anchorCtr="0" anchor="t" bIns="0" lIns="0" spcFirstLastPara="1" rIns="0" wrap="square" tIns="0">
-            <a:spAutoFit/>
-          </a:bodyPr>
-          <a:lstStyle/>
-          <a:p>
-            <a:pPr indent="0" lvl="0" marL="0" marR="0" rtl="0" algn="l">
-              <a:spcBef>
-                <a:spcPts val="0"/>
-              </a:spcBef>
-              <a:spcAft>
-                <a:spcPts val="0"/>
-              </a:spcAft>
-              <a:buNone/>
-            </a:pPr>
-            <a:r>
-              <a:rPr b="1" i="0" lang="en-US" sz="1900" u="none" cap="none" strike="noStrike">
-                <a:solidFill>
-                  <a:srgbClr val="F08443"/>
-                </a:solidFill>
-                <a:latin typeface="Arial"/>
-                <a:ea typeface="Arial"/>
-                <a:cs typeface="Arial"/>
-                <a:sym typeface="Arial"/>
-              </a:rPr>
-              <a:t>AWS</a:t>
-            </a:r>
-            <a:endParaRPr/>
-          </a:p>
-        </p:txBody>
-      </p:sp>
-      <p:sp>
-        <p:nvSpPr>
-          <p:cNvPr id="248" name="Google Shape;248;p23"/>
-          <p:cNvSpPr txBox="1"/>
-          <p:nvPr/>
-        </p:nvSpPr>
-        <p:spPr>
-          <a:xfrm>
-            <a:off x="3547872" y="5129784"/>
-            <a:ext cx="7863840" cy="594360"/>
-          </a:xfrm>
-          <a:prstGeom prst="rect">
-            <a:avLst/>
-          </a:prstGeom>
-          <a:noFill/>
-          <a:ln>
-            <a:noFill/>
-          </a:ln>
-        </p:spPr>
-        <p:txBody>
-          <a:bodyPr anchorCtr="0" anchor="t" bIns="0" lIns="0" spcFirstLastPara="1" rIns="0" wrap="square" tIns="0">
-            <a:spAutoFit/>
-          </a:bodyPr>
-          <a:lstStyle/>
-          <a:p>
-            <a:pPr indent="0" lvl="0" marL="0" marR="0" rtl="0" algn="l">
-              <a:spcBef>
-                <a:spcPts val="0"/>
-              </a:spcBef>
-              <a:spcAft>
-                <a:spcPts val="0"/>
-              </a:spcAft>
-              <a:buNone/>
-            </a:pPr>
-            <a:r>
-              <a:rPr b="0" i="0" lang="en-US" sz="1900" u="none" cap="none" strike="noStrike">
-                <a:solidFill>
-                  <a:srgbClr val="F6F7FA"/>
-                </a:solidFill>
-                <a:latin typeface="Arial"/>
-                <a:ea typeface="Arial"/>
-                <a:cs typeface="Arial"/>
-                <a:sym typeface="Arial"/>
-              </a:rPr>
-              <a:t>Rust powers projects such as Firecracker.</a:t>
-            </a:r>
-            <a:endParaRPr/>
-          </a:p>
-        </p:txBody>
-      </p:sp>
-    </p:spTree>
-  </p:cSld>
-  <p:clrMapOvr>
-    <a:masterClrMapping/>
-  </p:clrMapOvr>
-</p:sld>
-</file>
-
-<file path=ppt/slides/slide12.xml><?xml version="1.0" encoding="utf-8"?>
-<p:sld xmlns:a="http://schemas.openxmlformats.org/drawingml/2006/main" xmlns:r="http://schemas.openxmlformats.org/officeDocument/2006/relationships" xmlns:mc="http://schemas.openxmlformats.org/markup-compatibility/2006" xmlns:mv="urn:schemas-microsoft-com:mac:vml" xmlns:p="http://schemas.openxmlformats.org/presentationml/2006/main" xmlns:c="http://schemas.openxmlformats.org/drawingml/2006/chart" xmlns:dgm="http://schemas.openxmlformats.org/drawingml/2006/diagram" xmlns:o="urn:schemas-microsoft-com:office:office" xmlns:v="urn:schemas-microsoft-com:vml" xmlns:pvml="urn:schemas-microsoft-com:office:powerpoint" xmlns:com="http://schemas.openxmlformats.org/drawingml/2006/compatibility" xmlns:p14="http://schemas.microsoft.com/office/powerpoint/2010/main" xmlns:p15="http://schemas.microsoft.com/office/powerpoint/2012/main" xmlns:ahyp="http://schemas.microsoft.com/office/drawing/2018/hyperlinkcolor">
-  <p:cSld>
-    <p:spTree>
-      <p:nvGrpSpPr>
-        <p:cNvPr id="252" name="Shape 252"/>
-        <p:cNvGrpSpPr/>
-        <p:nvPr/>
-      </p:nvGrpSpPr>
-      <p:grpSpPr>
-        <a:xfrm>
-          <a:off x="0" y="0"/>
-          <a:ext cx="0" cy="0"/>
-          <a:chOff x="0" y="0"/>
-          <a:chExt cx="0" cy="0"/>
-        </a:xfrm>
-      </p:grpSpPr>
-      <p:sp>
-        <p:nvSpPr>
-          <p:cNvPr id="253" name="Google Shape;253;p24"/>
-          <p:cNvSpPr/>
-          <p:nvPr/>
-        </p:nvSpPr>
-        <p:spPr>
-          <a:xfrm>
-            <a:off x="0" y="0"/>
-            <a:ext cx="12191695" cy="6858000"/>
-          </a:xfrm>
-          <a:prstGeom prst="rect">
-            <a:avLst/>
-          </a:prstGeom>
-          <a:solidFill>
-            <a:srgbClr val="111B2B"/>
-          </a:solidFill>
-          <a:ln>
-            <a:noFill/>
-          </a:ln>
-          <a:effectLst>
-            <a:outerShdw blurRad="40000" rotWithShape="0" dir="5400000" dist="23000">
-              <a:srgbClr val="000000">
-                <a:alpha val="34902"/>
-              </a:srgbClr>
-            </a:outerShdw>
-          </a:effectLst>
-        </p:spPr>
-        <p:txBody>
-          <a:bodyPr anchorCtr="0" anchor="ctr" bIns="45700" lIns="91425" spcFirstLastPara="1" rIns="91425" wrap="square" tIns="45700">
-            <a:noAutofit/>
-          </a:bodyPr>
-          <a:lstStyle/>
-          <a:p>
-            <a:pPr indent="0" lvl="0" marL="0" marR="0" rtl="0" algn="ctr">
-              <a:spcBef>
-                <a:spcPts val="0"/>
-              </a:spcBef>
-              <a:spcAft>
-                <a:spcPts val="0"/>
-              </a:spcAft>
-              <a:buNone/>
-            </a:pPr>
-            <a:r>
-              <a:t/>
-            </a:r>
-            <a:endParaRPr b="0" i="0" sz="1800" u="none" cap="none" strike="noStrike">
-              <a:solidFill>
-                <a:schemeClr val="dk1"/>
-              </a:solidFill>
-              <a:latin typeface="Calibri"/>
-              <a:ea typeface="Calibri"/>
-              <a:cs typeface="Calibri"/>
-              <a:sym typeface="Calibri"/>
-            </a:endParaRPr>
-          </a:p>
-        </p:txBody>
-      </p:sp>
-      <p:sp>
-        <p:nvSpPr>
-          <p:cNvPr id="254" name="Google Shape;254;p24"/>
-          <p:cNvSpPr/>
-          <p:nvPr/>
-        </p:nvSpPr>
-        <p:spPr>
-          <a:xfrm>
-            <a:off x="411480" y="393192"/>
-            <a:ext cx="73152" cy="429768"/>
-          </a:xfrm>
-          <a:prstGeom prst="rect">
-            <a:avLst/>
-          </a:prstGeom>
-          <a:solidFill>
-            <a:srgbClr val="F08443"/>
-          </a:solidFill>
-          <a:ln>
-            <a:noFill/>
-          </a:ln>
-          <a:effectLst>
-            <a:outerShdw blurRad="40000" rotWithShape="0" dir="5400000" dist="23000">
-              <a:srgbClr val="000000">
-                <a:alpha val="34902"/>
-              </a:srgbClr>
-            </a:outerShdw>
-          </a:effectLst>
-        </p:spPr>
-        <p:txBody>
-          <a:bodyPr anchorCtr="0" anchor="ctr" bIns="45700" lIns="91425" spcFirstLastPara="1" rIns="91425" wrap="square" tIns="45700">
-            <a:noAutofit/>
-          </a:bodyPr>
-          <a:lstStyle/>
-          <a:p>
-            <a:pPr indent="0" lvl="0" marL="0" marR="0" rtl="0" algn="ctr">
-              <a:spcBef>
-                <a:spcPts val="0"/>
-              </a:spcBef>
-              <a:spcAft>
-                <a:spcPts val="0"/>
-              </a:spcAft>
-              <a:buNone/>
-            </a:pPr>
-            <a:r>
-              <a:t/>
-            </a:r>
-            <a:endParaRPr b="0" i="0" sz="1800" u="none" cap="none" strike="noStrike">
-              <a:solidFill>
-                <a:schemeClr val="dk1"/>
-              </a:solidFill>
-              <a:latin typeface="Calibri"/>
-              <a:ea typeface="Calibri"/>
-              <a:cs typeface="Calibri"/>
-              <a:sym typeface="Calibri"/>
-            </a:endParaRPr>
-          </a:p>
-        </p:txBody>
-      </p:sp>
-      <p:sp>
-        <p:nvSpPr>
-          <p:cNvPr id="255" name="Google Shape;255;p24"/>
-          <p:cNvSpPr txBox="1"/>
-          <p:nvPr/>
-        </p:nvSpPr>
-        <p:spPr>
-          <a:xfrm>
-            <a:off x="612648" y="411480"/>
-            <a:ext cx="7315200" cy="274320"/>
-          </a:xfrm>
-          <a:prstGeom prst="rect">
-            <a:avLst/>
-          </a:prstGeom>
-          <a:noFill/>
-          <a:ln>
-            <a:noFill/>
-          </a:ln>
-        </p:spPr>
-        <p:txBody>
-          <a:bodyPr anchorCtr="0" anchor="t" bIns="0" lIns="0" spcFirstLastPara="1" rIns="0" wrap="square" tIns="0">
-            <a:spAutoFit/>
-          </a:bodyPr>
-          <a:lstStyle/>
-          <a:p>
-            <a:pPr indent="0" lvl="0" marL="0" marR="0" rtl="0" algn="l">
-              <a:spcBef>
-                <a:spcPts val="0"/>
-              </a:spcBef>
-              <a:spcAft>
-                <a:spcPts val="0"/>
-              </a:spcAft>
-              <a:buNone/>
-            </a:pPr>
-            <a:r>
-              <a:rPr b="1" i="0" lang="en-US" sz="1100" u="none" cap="none" strike="noStrike">
-                <a:solidFill>
-                  <a:srgbClr val="BDC8D6"/>
-                </a:solidFill>
-                <a:latin typeface="Arial"/>
-                <a:ea typeface="Arial"/>
-                <a:cs typeface="Arial"/>
-                <a:sym typeface="Arial"/>
-              </a:rPr>
-              <a:t>CEP146  /  SOFTWARE DEVELOPMENT CURRENT EVENT</a:t>
-            </a:r>
-            <a:endParaRPr/>
-          </a:p>
-        </p:txBody>
-      </p:sp>
-      <p:sp>
-        <p:nvSpPr>
-          <p:cNvPr id="256" name="Google Shape;256;p24"/>
-          <p:cNvSpPr txBox="1"/>
-          <p:nvPr/>
-        </p:nvSpPr>
-        <p:spPr>
-          <a:xfrm>
-            <a:off x="621792" y="978408"/>
-            <a:ext cx="10972800" cy="731520"/>
-          </a:xfrm>
-          <a:prstGeom prst="rect">
-            <a:avLst/>
-          </a:prstGeom>
-          <a:noFill/>
-          <a:ln>
-            <a:noFill/>
-          </a:ln>
-        </p:spPr>
-        <p:txBody>
-          <a:bodyPr anchorCtr="0" anchor="t" bIns="0" lIns="0" spcFirstLastPara="1" rIns="0" wrap="square" tIns="0">
-            <a:spAutoFit/>
-          </a:bodyPr>
-          <a:lstStyle/>
-          <a:p>
-            <a:pPr indent="0" lvl="0" marL="0" marR="0" rtl="0" algn="l">
-              <a:spcBef>
-                <a:spcPts val="0"/>
-              </a:spcBef>
-              <a:spcAft>
-                <a:spcPts val="0"/>
-              </a:spcAft>
-              <a:buNone/>
-            </a:pPr>
-            <a:r>
-              <a:rPr b="1" i="0" lang="en-US" sz="3100" u="none" cap="none" strike="noStrike">
-                <a:solidFill>
-                  <a:srgbClr val="F6F7FA"/>
-                </a:solidFill>
-                <a:latin typeface="Arial"/>
-                <a:ea typeface="Arial"/>
-                <a:cs typeface="Arial"/>
-                <a:sym typeface="Arial"/>
-              </a:rPr>
-              <a:t>Challenges and final thoughts</a:t>
-            </a:r>
-            <a:endParaRPr/>
-          </a:p>
-        </p:txBody>
-      </p:sp>
-      <p:sp>
-        <p:nvSpPr>
-          <p:cNvPr id="257" name="Google Shape;257;p24"/>
-          <p:cNvSpPr txBox="1"/>
-          <p:nvPr/>
-        </p:nvSpPr>
-        <p:spPr>
-          <a:xfrm>
-            <a:off x="9875520" y="6446520"/>
-            <a:ext cx="1828800" cy="182880"/>
-          </a:xfrm>
-          <a:prstGeom prst="rect">
-            <a:avLst/>
-          </a:prstGeom>
-          <a:noFill/>
-          <a:ln>
-            <a:noFill/>
-          </a:ln>
-        </p:spPr>
-        <p:txBody>
-          <a:bodyPr anchorCtr="0" anchor="t" bIns="0" lIns="0" spcFirstLastPara="1" rIns="0" wrap="square" tIns="0">
-            <a:spAutoFit/>
-          </a:bodyPr>
-          <a:lstStyle/>
-          <a:p>
-            <a:pPr indent="0" lvl="0" marL="0" marR="0" rtl="0" algn="l">
-              <a:spcBef>
-                <a:spcPts val="0"/>
-              </a:spcBef>
-              <a:spcAft>
-                <a:spcPts val="0"/>
-              </a:spcAft>
-              <a:buNone/>
-            </a:pPr>
-            <a:r>
-              <a:rPr b="0" i="0" lang="en-US" sz="900" u="none" cap="none" strike="noStrike">
-                <a:solidFill>
-                  <a:srgbClr val="BDC8D6"/>
-                </a:solidFill>
-                <a:latin typeface="Arial"/>
-                <a:ea typeface="Arial"/>
-                <a:cs typeface="Arial"/>
-                <a:sym typeface="Arial"/>
-              </a:rPr>
-              <a:t>06  /  RUST IN 2026</a:t>
-            </a:r>
-            <a:endParaRPr/>
-          </a:p>
-        </p:txBody>
-      </p:sp>
-      <p:sp>
-        <p:nvSpPr>
-          <p:cNvPr id="258" name="Google Shape;258;p24"/>
-          <p:cNvSpPr/>
-          <p:nvPr/>
-        </p:nvSpPr>
-        <p:spPr>
-          <a:xfrm>
-            <a:off x="758952" y="2103120"/>
-            <a:ext cx="100584" cy="100584"/>
-          </a:xfrm>
-          <a:prstGeom prst="rect">
-            <a:avLst/>
-          </a:prstGeom>
-          <a:solidFill>
-            <a:srgbClr val="F08443"/>
-          </a:solidFill>
-          <a:ln>
-            <a:noFill/>
-          </a:ln>
-          <a:effectLst>
-            <a:outerShdw blurRad="40000" rotWithShape="0" dir="5400000" dist="23000">
-              <a:srgbClr val="000000">
-                <a:alpha val="34902"/>
-              </a:srgbClr>
-            </a:outerShdw>
-          </a:effectLst>
-        </p:spPr>
-        <p:txBody>
-          <a:bodyPr anchorCtr="0" anchor="ctr" bIns="45700" lIns="91425" spcFirstLastPara="1" rIns="91425" wrap="square" tIns="45700">
-            <a:noAutofit/>
-          </a:bodyPr>
-          <a:lstStyle/>
-          <a:p>
-            <a:pPr indent="0" lvl="0" marL="0" marR="0" rtl="0" algn="ctr">
-              <a:spcBef>
-                <a:spcPts val="0"/>
-              </a:spcBef>
-              <a:spcAft>
-                <a:spcPts val="0"/>
-              </a:spcAft>
-              <a:buNone/>
-            </a:pPr>
-            <a:r>
-              <a:t/>
-            </a:r>
-            <a:endParaRPr b="0" i="0" sz="1800" u="none" cap="none" strike="noStrike">
-              <a:solidFill>
-                <a:schemeClr val="dk1"/>
-              </a:solidFill>
-              <a:latin typeface="Calibri"/>
-              <a:ea typeface="Calibri"/>
-              <a:cs typeface="Calibri"/>
-              <a:sym typeface="Calibri"/>
-            </a:endParaRPr>
-          </a:p>
-        </p:txBody>
-      </p:sp>
-      <p:sp>
-        <p:nvSpPr>
-          <p:cNvPr id="259" name="Google Shape;259;p24"/>
-          <p:cNvSpPr txBox="1"/>
-          <p:nvPr/>
-        </p:nvSpPr>
-        <p:spPr>
-          <a:xfrm>
-            <a:off x="1042415" y="1993392"/>
-            <a:ext cx="10241280" cy="685800"/>
-          </a:xfrm>
-          <a:prstGeom prst="rect">
-            <a:avLst/>
-          </a:prstGeom>
-          <a:noFill/>
-          <a:ln>
-            <a:noFill/>
-          </a:ln>
-        </p:spPr>
-        <p:txBody>
-          <a:bodyPr anchorCtr="0" anchor="t" bIns="0" lIns="0" spcFirstLastPara="1" rIns="0" wrap="square" tIns="0">
-            <a:spAutoFit/>
-          </a:bodyPr>
-          <a:lstStyle/>
-          <a:p>
-            <a:pPr indent="0" lvl="0" marL="0" marR="0" rtl="0" algn="l">
-              <a:spcBef>
-                <a:spcPts val="0"/>
-              </a:spcBef>
-              <a:spcAft>
-                <a:spcPts val="0"/>
-              </a:spcAft>
-              <a:buNone/>
-            </a:pPr>
-            <a:r>
-              <a:rPr b="0" i="0" lang="en-US" sz="2000" u="none" cap="none" strike="noStrike">
-                <a:solidFill>
-                  <a:srgbClr val="F6F7FA"/>
-                </a:solidFill>
-                <a:latin typeface="Arial"/>
-                <a:ea typeface="Arial"/>
-                <a:cs typeface="Arial"/>
-                <a:sym typeface="Arial"/>
-              </a:rPr>
-              <a:t>Rust can be difficult to learn, especially ownership rules</a:t>
-            </a:r>
-            <a:endParaRPr/>
-          </a:p>
-        </p:txBody>
-      </p:sp>
-      <p:sp>
-        <p:nvSpPr>
-          <p:cNvPr id="260" name="Google Shape;260;p24"/>
-          <p:cNvSpPr/>
-          <p:nvPr/>
-        </p:nvSpPr>
-        <p:spPr>
-          <a:xfrm>
-            <a:off x="758952" y="3072384"/>
-            <a:ext cx="100584" cy="100584"/>
-          </a:xfrm>
-          <a:prstGeom prst="rect">
-            <a:avLst/>
-          </a:prstGeom>
-          <a:solidFill>
-            <a:srgbClr val="F08443"/>
-          </a:solidFill>
-          <a:ln>
-            <a:noFill/>
-          </a:ln>
-          <a:effectLst>
-            <a:outerShdw blurRad="40000" rotWithShape="0" dir="5400000" dist="23000">
-              <a:srgbClr val="000000">
-                <a:alpha val="34902"/>
-              </a:srgbClr>
-            </a:outerShdw>
-          </a:effectLst>
-        </p:spPr>
-        <p:txBody>
-          <a:bodyPr anchorCtr="0" anchor="ctr" bIns="45700" lIns="91425" spcFirstLastPara="1" rIns="91425" wrap="square" tIns="45700">
-            <a:noAutofit/>
-          </a:bodyPr>
-          <a:lstStyle/>
-          <a:p>
-            <a:pPr indent="0" lvl="0" marL="0" marR="0" rtl="0" algn="ctr">
-              <a:spcBef>
-                <a:spcPts val="0"/>
-              </a:spcBef>
-              <a:spcAft>
-                <a:spcPts val="0"/>
-              </a:spcAft>
-              <a:buNone/>
-            </a:pPr>
-            <a:r>
-              <a:t/>
-            </a:r>
-            <a:endParaRPr b="0" i="0" sz="1800" u="none" cap="none" strike="noStrike">
-              <a:solidFill>
-                <a:schemeClr val="dk1"/>
-              </a:solidFill>
-              <a:latin typeface="Calibri"/>
-              <a:ea typeface="Calibri"/>
-              <a:cs typeface="Calibri"/>
-              <a:sym typeface="Calibri"/>
-            </a:endParaRPr>
-          </a:p>
-        </p:txBody>
-      </p:sp>
-      <p:sp>
-        <p:nvSpPr>
-          <p:cNvPr id="261" name="Google Shape;261;p24"/>
-          <p:cNvSpPr txBox="1"/>
-          <p:nvPr/>
-        </p:nvSpPr>
-        <p:spPr>
-          <a:xfrm>
-            <a:off x="1042415" y="2962656"/>
-            <a:ext cx="10241280" cy="685800"/>
-          </a:xfrm>
-          <a:prstGeom prst="rect">
-            <a:avLst/>
-          </a:prstGeom>
-          <a:noFill/>
-          <a:ln>
-            <a:noFill/>
-          </a:ln>
-        </p:spPr>
-        <p:txBody>
-          <a:bodyPr anchorCtr="0" anchor="t" bIns="0" lIns="0" spcFirstLastPara="1" rIns="0" wrap="square" tIns="0">
-            <a:spAutoFit/>
-          </a:bodyPr>
-          <a:lstStyle/>
-          <a:p>
-            <a:pPr indent="0" lvl="0" marL="0" marR="0" rtl="0" algn="l">
-              <a:spcBef>
-                <a:spcPts val="0"/>
-              </a:spcBef>
-              <a:spcAft>
-                <a:spcPts val="0"/>
-              </a:spcAft>
-              <a:buNone/>
-            </a:pPr>
-            <a:r>
-              <a:rPr b="0" i="0" lang="en-US" sz="2000" u="none" cap="none" strike="noStrike">
-                <a:solidFill>
-                  <a:srgbClr val="F6F7FA"/>
-                </a:solidFill>
-                <a:latin typeface="Arial"/>
-                <a:ea typeface="Arial"/>
-                <a:cs typeface="Arial"/>
-                <a:sym typeface="Arial"/>
-              </a:rPr>
-              <a:t>Compiler checks can make development feel slower at first</a:t>
-            </a:r>
-            <a:endParaRPr/>
-          </a:p>
-        </p:txBody>
-      </p:sp>
-      <p:sp>
-        <p:nvSpPr>
-          <p:cNvPr id="262" name="Google Shape;262;p24"/>
-          <p:cNvSpPr/>
-          <p:nvPr/>
-        </p:nvSpPr>
-        <p:spPr>
-          <a:xfrm>
-            <a:off x="758952" y="4050791"/>
-            <a:ext cx="100584" cy="100584"/>
-          </a:xfrm>
-          <a:prstGeom prst="rect">
-            <a:avLst/>
-          </a:prstGeom>
-          <a:solidFill>
-            <a:srgbClr val="F08443"/>
-          </a:solidFill>
-          <a:ln>
-            <a:noFill/>
-          </a:ln>
-          <a:effectLst>
-            <a:outerShdw blurRad="40000" rotWithShape="0" dir="5400000" dist="23000">
-              <a:srgbClr val="000000">
-                <a:alpha val="34902"/>
-              </a:srgbClr>
-            </a:outerShdw>
-          </a:effectLst>
-        </p:spPr>
-        <p:txBody>
-          <a:bodyPr anchorCtr="0" anchor="ctr" bIns="45700" lIns="91425" spcFirstLastPara="1" rIns="91425" wrap="square" tIns="45700">
-            <a:noAutofit/>
-          </a:bodyPr>
-          <a:lstStyle/>
-          <a:p>
-            <a:pPr indent="0" lvl="0" marL="0" marR="0" rtl="0" algn="ctr">
-              <a:spcBef>
-                <a:spcPts val="0"/>
-              </a:spcBef>
-              <a:spcAft>
-                <a:spcPts val="0"/>
-              </a:spcAft>
-              <a:buNone/>
-            </a:pPr>
-            <a:r>
-              <a:t/>
-            </a:r>
-            <a:endParaRPr b="0" i="0" sz="1800" u="none" cap="none" strike="noStrike">
-              <a:solidFill>
-                <a:schemeClr val="dk1"/>
-              </a:solidFill>
-              <a:latin typeface="Calibri"/>
-              <a:ea typeface="Calibri"/>
-              <a:cs typeface="Calibri"/>
-              <a:sym typeface="Calibri"/>
-            </a:endParaRPr>
-          </a:p>
-        </p:txBody>
-      </p:sp>
-      <p:sp>
-        <p:nvSpPr>
-          <p:cNvPr id="263" name="Google Shape;263;p24"/>
-          <p:cNvSpPr txBox="1"/>
-          <p:nvPr/>
-        </p:nvSpPr>
-        <p:spPr>
-          <a:xfrm>
-            <a:off x="1042415" y="3941063"/>
-            <a:ext cx="10241280" cy="685800"/>
-          </a:xfrm>
-          <a:prstGeom prst="rect">
-            <a:avLst/>
-          </a:prstGeom>
-          <a:noFill/>
-          <a:ln>
-            <a:noFill/>
-          </a:ln>
-        </p:spPr>
-        <p:txBody>
-          <a:bodyPr anchorCtr="0" anchor="t" bIns="0" lIns="0" spcFirstLastPara="1" rIns="0" wrap="square" tIns="0">
-            <a:spAutoFit/>
-          </a:bodyPr>
-          <a:lstStyle/>
-          <a:p>
-            <a:pPr indent="0" lvl="0" marL="0" marR="0" rtl="0" algn="l">
-              <a:spcBef>
-                <a:spcPts val="0"/>
-              </a:spcBef>
-              <a:spcAft>
-                <a:spcPts val="0"/>
-              </a:spcAft>
-              <a:buNone/>
-            </a:pPr>
-            <a:r>
-              <a:rPr b="0" i="0" lang="en-US" sz="2000" u="none" cap="none" strike="noStrike">
-                <a:solidFill>
-                  <a:srgbClr val="F6F7FA"/>
-                </a:solidFill>
-                <a:latin typeface="Arial"/>
-                <a:ea typeface="Arial"/>
-                <a:cs typeface="Arial"/>
-                <a:sym typeface="Arial"/>
-              </a:rPr>
-              <a:t>It will not replace every C or C++ program</a:t>
-            </a:r>
-            <a:endParaRPr/>
-          </a:p>
-        </p:txBody>
-      </p:sp>
-      <p:sp>
-        <p:nvSpPr>
-          <p:cNvPr id="264" name="Google Shape;264;p24"/>
-          <p:cNvSpPr/>
-          <p:nvPr/>
-        </p:nvSpPr>
-        <p:spPr>
-          <a:xfrm>
-            <a:off x="749808" y="5074920"/>
-            <a:ext cx="10698480" cy="868680"/>
-          </a:xfrm>
-          <a:prstGeom prst="rect">
-            <a:avLst/>
-          </a:prstGeom>
-          <a:solidFill>
-            <a:srgbClr val="1D2B3F"/>
-          </a:solidFill>
-          <a:ln>
-            <a:noFill/>
-          </a:ln>
-          <a:effectLst>
-            <a:outerShdw blurRad="40000" rotWithShape="0" dir="5400000" dist="23000">
-              <a:srgbClr val="000000">
-                <a:alpha val="34902"/>
-              </a:srgbClr>
-            </a:outerShdw>
-          </a:effectLst>
-        </p:spPr>
-        <p:txBody>
-          <a:bodyPr anchorCtr="0" anchor="ctr" bIns="45700" lIns="91425" spcFirstLastPara="1" rIns="91425" wrap="square" tIns="45700">
-            <a:noAutofit/>
-          </a:bodyPr>
-          <a:lstStyle/>
-          <a:p>
-            <a:pPr indent="0" lvl="0" marL="0" marR="0" rtl="0" algn="ctr">
-              <a:spcBef>
-                <a:spcPts val="0"/>
-              </a:spcBef>
-              <a:spcAft>
-                <a:spcPts val="0"/>
-              </a:spcAft>
-              <a:buNone/>
-            </a:pPr>
-            <a:r>
-              <a:t/>
-            </a:r>
-            <a:endParaRPr b="0" i="0" sz="1800" u="none" cap="none" strike="noStrike">
-              <a:solidFill>
-                <a:schemeClr val="dk1"/>
-              </a:solidFill>
-              <a:latin typeface="Calibri"/>
-              <a:ea typeface="Calibri"/>
-              <a:cs typeface="Calibri"/>
-              <a:sym typeface="Calibri"/>
-            </a:endParaRPr>
-          </a:p>
-        </p:txBody>
-      </p:sp>
-      <p:sp>
-        <p:nvSpPr>
-          <p:cNvPr id="265" name="Google Shape;265;p24"/>
-          <p:cNvSpPr txBox="1"/>
-          <p:nvPr/>
-        </p:nvSpPr>
-        <p:spPr>
-          <a:xfrm>
-            <a:off x="1005840" y="5330952"/>
-            <a:ext cx="10241280" cy="411480"/>
-          </a:xfrm>
-          <a:prstGeom prst="rect">
-            <a:avLst/>
-          </a:prstGeom>
-          <a:noFill/>
-          <a:ln>
-            <a:noFill/>
-          </a:ln>
-        </p:spPr>
-        <p:txBody>
-          <a:bodyPr anchorCtr="0" anchor="t" bIns="0" lIns="0" spcFirstLastPara="1" rIns="0" wrap="square" tIns="0">
-            <a:spAutoFit/>
-          </a:bodyPr>
-          <a:lstStyle/>
-          <a:p>
-            <a:pPr indent="0" lvl="0" marL="0" marR="0" rtl="0" algn="l">
-              <a:spcBef>
-                <a:spcPts val="0"/>
-              </a:spcBef>
-              <a:spcAft>
-                <a:spcPts val="0"/>
-              </a:spcAft>
-              <a:buNone/>
-            </a:pPr>
-            <a:r>
-              <a:rPr b="1" i="0" lang="en-US" sz="2100" u="none" cap="none" strike="noStrike">
-                <a:solidFill>
-                  <a:srgbClr val="F6F7FA"/>
-                </a:solidFill>
-                <a:latin typeface="Arial"/>
-                <a:ea typeface="Arial"/>
-                <a:cs typeface="Arial"/>
-                <a:sym typeface="Arial"/>
-              </a:rPr>
-              <a:t>Rust is becoming a serious option for safer systems software.</a:t>
+              <a:t>04  /  RUST IN 2026</a:t>
             </a:r>
             <a:endParaRPr/>
           </a:p>
@@ -18295,23 +16984,7 @@
                   <a:srgbClr val="F6F7FA"/>
                 </a:solidFill>
               </a:rPr>
-              <a:t>Checked </a:t>
-            </a:r>
-            <a:r>
-              <a:rPr lang="en-US" sz="2300">
-                <a:solidFill>
-                  <a:srgbClr val="F6F7FA"/>
-                </a:solidFill>
-              </a:rPr>
-              <a:t>before</a:t>
-            </a:r>
-            <a:r>
-              <a:rPr lang="en-US" sz="2300">
-                <a:solidFill>
-                  <a:srgbClr val="F6F7FA"/>
-                </a:solidFill>
-              </a:rPr>
-              <a:t> the program runs, not during it.</a:t>
+              <a:t>Checked before the program runs, not during it.</a:t>
             </a:r>
             <a:endParaRPr sz="1600"/>
           </a:p>
@@ -18575,7 +17248,7 @@
         <p:spPr>
           <a:xfrm>
             <a:off x="621792" y="978408"/>
-            <a:ext cx="10972800" cy="731520"/>
+            <a:ext cx="10972800" cy="477300"/>
           </a:xfrm>
           <a:prstGeom prst="rect">
             <a:avLst/>
@@ -18610,7 +17283,27 @@
                 <a:cs typeface="Arial"/>
                 <a:sym typeface="Arial"/>
               </a:rPr>
-              <a:t>Rust and the Linux kernel</a:t>
+              <a:t>Where is Rust being </a:t>
+            </a:r>
+            <a:r>
+              <a:rPr b="1" lang="en-US" sz="3100">
+                <a:solidFill>
+                  <a:srgbClr val="F6F7FA"/>
+                </a:solidFill>
+              </a:rPr>
+              <a:t>U</a:t>
+            </a:r>
+            <a:r>
+              <a:rPr b="1" i="0" lang="en-US" sz="3100" u="none" cap="none" strike="noStrike">
+                <a:solidFill>
+                  <a:srgbClr val="F6F7FA"/>
+                </a:solidFill>
+                <a:latin typeface="Arial"/>
+                <a:ea typeface="Arial"/>
+                <a:cs typeface="Arial"/>
+                <a:sym typeface="Arial"/>
+              </a:rPr>
+              <a:t>sed?</a:t>
             </a:r>
             <a:endParaRPr/>
           </a:p>
@@ -18660,7 +17353,7 @@
                 <a:cs typeface="Arial"/>
                 <a:sym typeface="Arial"/>
               </a:rPr>
-              <a:t>03  /  RUST IN 2026</a:t>
+              <a:t>05  /  RUST IN 2026</a:t>
             </a:r>
             <a:endParaRPr/>
           </a:p>
@@ -18669,119 +17362,19 @@
       <p:sp>
         <p:nvSpPr>
           <p:cNvPr id="205" name="Google Shape;205;p21"/>
-          <p:cNvSpPr txBox="1"/>
-          <p:nvPr/>
-        </p:nvSpPr>
-        <p:spPr>
-          <a:xfrm>
-            <a:off x="1051560" y="2039112"/>
-            <a:ext cx="1828800" cy="548640"/>
-          </a:xfrm>
-          <a:prstGeom prst="rect">
-            <a:avLst/>
-          </a:prstGeom>
-          <a:noFill/>
-          <a:ln>
-            <a:noFill/>
-          </a:ln>
-        </p:spPr>
-        <p:txBody>
-          <a:bodyPr anchorCtr="0" anchor="t" bIns="0" lIns="0" spcFirstLastPara="1" rIns="0" wrap="square" tIns="0">
-            <a:spAutoFit/>
-          </a:bodyPr>
-          <a:lstStyle/>
-          <a:p>
-            <a:pPr indent="0" lvl="0" marL="0" marR="0" rtl="0" algn="l">
-              <a:spcBef>
-                <a:spcPts val="0"/>
-              </a:spcBef>
-              <a:spcAft>
-                <a:spcPts val="0"/>
-              </a:spcAft>
-              <a:buNone/>
-            </a:pPr>
-            <a:r>
-              <a:rPr b="1" i="0" lang="en-US" sz="2600" u="none" cap="none" strike="noStrike">
-                <a:solidFill>
-                  <a:srgbClr val="F08443"/>
-                </a:solidFill>
-                <a:latin typeface="Arial"/>
-                <a:ea typeface="Arial"/>
-                <a:cs typeface="Arial"/>
-                <a:sym typeface="Arial"/>
-              </a:rPr>
-              <a:t>2022</a:t>
-            </a:r>
-            <a:endParaRPr/>
-          </a:p>
-        </p:txBody>
-      </p:sp>
-      <p:sp>
-        <p:nvSpPr>
-          <p:cNvPr id="206" name="Google Shape;206;p21"/>
-          <p:cNvSpPr txBox="1"/>
-          <p:nvPr/>
-        </p:nvSpPr>
-        <p:spPr>
-          <a:xfrm>
-            <a:off x="2880360" y="2011680"/>
-            <a:ext cx="8229600" cy="694944"/>
-          </a:xfrm>
-          <a:prstGeom prst="rect">
-            <a:avLst/>
-          </a:prstGeom>
-          <a:noFill/>
-          <a:ln>
-            <a:noFill/>
-          </a:ln>
-        </p:spPr>
-        <p:txBody>
-          <a:bodyPr anchorCtr="0" anchor="t" bIns="0" lIns="0" spcFirstLastPara="1" rIns="0" wrap="square" tIns="0">
-            <a:spAutoFit/>
-          </a:bodyPr>
-          <a:lstStyle/>
-          <a:p>
-            <a:pPr indent="0" lvl="0" marL="0" marR="0" rtl="0" algn="l">
-              <a:spcBef>
-                <a:spcPts val="0"/>
-              </a:spcBef>
-              <a:spcAft>
-                <a:spcPts val="0"/>
-              </a:spcAft>
-              <a:buNone/>
-            </a:pPr>
-            <a:r>
-              <a:rPr b="0" i="0" lang="en-US" sz="2100" u="none" cap="none" strike="noStrike">
-                <a:solidFill>
-                  <a:srgbClr val="F6F7FA"/>
-                </a:solidFill>
-                <a:latin typeface="Arial"/>
-                <a:ea typeface="Arial"/>
-                <a:cs typeface="Arial"/>
-                <a:sym typeface="Arial"/>
-              </a:rPr>
-              <a:t>Rust support entered the Linux kernel.</a:t>
-            </a:r>
-            <a:endParaRPr/>
-          </a:p>
-        </p:txBody>
-      </p:sp>
-      <p:sp>
-        <p:nvSpPr>
-          <p:cNvPr id="207" name="Google Shape;207;p21"/>
           <p:cNvSpPr/>
           <p:nvPr/>
         </p:nvSpPr>
         <p:spPr>
           <a:xfrm>
-            <a:off x="1060704" y="2926080"/>
-            <a:ext cx="10058400" cy="22860"/>
+            <a:off x="749808" y="1938528"/>
+            <a:ext cx="2514600" cy="731520"/>
           </a:xfrm>
           <a:prstGeom prst="rect">
             <a:avLst/>
           </a:prstGeom>
           <a:solidFill>
-            <a:srgbClr val="BDC8D6"/>
+            <a:srgbClr val="1D2B3F"/>
           </a:solidFill>
           <a:ln>
             <a:noFill/>
@@ -18826,14 +17419,14 @@
       </p:sp>
       <p:sp>
         <p:nvSpPr>
-          <p:cNvPr id="208" name="Google Shape;208;p21"/>
+          <p:cNvPr id="206" name="Google Shape;206;p21"/>
           <p:cNvSpPr txBox="1"/>
           <p:nvPr/>
         </p:nvSpPr>
         <p:spPr>
           <a:xfrm>
-            <a:off x="1051560" y="3328416"/>
-            <a:ext cx="2011680" cy="548640"/>
+            <a:off x="950976" y="2093976"/>
+            <a:ext cx="2194560" cy="393192"/>
           </a:xfrm>
           <a:prstGeom prst="rect">
             <a:avLst/>
@@ -18859,7 +17452,7 @@
               <a:buNone/>
             </a:pPr>
             <a:r>
-              <a:rPr b="1" i="0" lang="en-US" sz="2500" u="none" cap="none" strike="noStrike">
+              <a:rPr b="1" i="0" lang="en-US" sz="1900" u="none" cap="none" strike="noStrike">
                 <a:solidFill>
                   <a:srgbClr val="F08443"/>
                 </a:solidFill>
@@ -18868,7 +17461,7 @@
                 <a:cs typeface="Arial"/>
                 <a:sym typeface="Arial"/>
               </a:rPr>
-              <a:t>Dec 2025</a:t>
+              <a:t>Linux</a:t>
             </a:r>
             <a:endParaRPr/>
           </a:p>
@@ -18876,14 +17469,14 @@
       </p:sp>
       <p:sp>
         <p:nvSpPr>
-          <p:cNvPr id="209" name="Google Shape;209;p21"/>
+          <p:cNvPr id="207" name="Google Shape;207;p21"/>
           <p:cNvSpPr txBox="1"/>
           <p:nvPr/>
         </p:nvSpPr>
         <p:spPr>
           <a:xfrm>
-            <a:off x="2880360" y="3310128"/>
-            <a:ext cx="8138160" cy="868680"/>
+            <a:off x="3547872" y="2057400"/>
+            <a:ext cx="7863840" cy="594360"/>
           </a:xfrm>
           <a:prstGeom prst="rect">
             <a:avLst/>
@@ -18909,7 +17502,7 @@
               <a:buNone/>
             </a:pPr>
             <a:r>
-              <a:rPr b="0" i="0" lang="en-US" sz="2100" u="none" cap="none" strike="noStrike">
+              <a:rPr b="0" i="0" lang="en-US" sz="1900" u="none" cap="none" strike="noStrike">
                 <a:solidFill>
                   <a:srgbClr val="F6F7FA"/>
                 </a:solidFill>
@@ -18918,7 +17511,7 @@
                 <a:cs typeface="Arial"/>
                 <a:sym typeface="Arial"/>
               </a:rPr>
-              <a:t>Linux maintainers said Rust was no longer experimental.</a:t>
+              <a:t>Developers can write some kernel components in Rust.</a:t>
             </a:r>
             <a:endParaRPr/>
           </a:p>
@@ -18926,20 +17519,20 @@
       </p:sp>
       <p:sp>
         <p:nvSpPr>
-          <p:cNvPr id="210" name="Google Shape;210;p21"/>
+          <p:cNvPr id="208" name="Google Shape;208;p21"/>
           <p:cNvSpPr/>
           <p:nvPr/>
         </p:nvSpPr>
         <p:spPr>
           <a:xfrm>
-            <a:off x="1060704" y="4343400"/>
-            <a:ext cx="10058400" cy="22860"/>
+            <a:off x="749808" y="2962656"/>
+            <a:ext cx="2514600" cy="731520"/>
           </a:xfrm>
           <a:prstGeom prst="rect">
             <a:avLst/>
           </a:prstGeom>
           <a:solidFill>
-            <a:srgbClr val="BDC8D6"/>
+            <a:srgbClr val="1D2B3F"/>
           </a:solidFill>
           <a:ln>
             <a:noFill/>
@@ -18984,14 +17577,14 @@
       </p:sp>
       <p:sp>
         <p:nvSpPr>
-          <p:cNvPr id="211" name="Google Shape;211;p21"/>
+          <p:cNvPr id="209" name="Google Shape;209;p21"/>
           <p:cNvSpPr txBox="1"/>
           <p:nvPr/>
         </p:nvSpPr>
         <p:spPr>
           <a:xfrm>
-            <a:off x="1051560" y="4754880"/>
-            <a:ext cx="1828800" cy="548640"/>
+            <a:off x="950976" y="3118104"/>
+            <a:ext cx="2194560" cy="393192"/>
           </a:xfrm>
           <a:prstGeom prst="rect">
             <a:avLst/>
@@ -19017,7 +17610,7 @@
               <a:buNone/>
             </a:pPr>
             <a:r>
-              <a:rPr b="1" i="0" lang="en-US" sz="2600" u="none" cap="none" strike="noStrike">
+              <a:rPr b="1" i="0" lang="en-US" sz="1900" u="none" cap="none" strike="noStrike">
                 <a:solidFill>
                   <a:srgbClr val="F08443"/>
                 </a:solidFill>
@@ -19026,7 +17619,7 @@
                 <a:cs typeface="Arial"/>
                 <a:sym typeface="Arial"/>
               </a:rPr>
-              <a:t>2026</a:t>
+              <a:t>Google / Android</a:t>
             </a:r>
             <a:endParaRPr/>
           </a:p>
@@ -19034,14 +17627,14 @@
       </p:sp>
       <p:sp>
         <p:nvSpPr>
-          <p:cNvPr id="212" name="Google Shape;212;p21"/>
+          <p:cNvPr id="210" name="Google Shape;210;p21"/>
           <p:cNvSpPr txBox="1"/>
           <p:nvPr/>
         </p:nvSpPr>
         <p:spPr>
           <a:xfrm>
-            <a:off x="2880360" y="4736592"/>
-            <a:ext cx="8229600" cy="731520"/>
+            <a:off x="3547872" y="3081528"/>
+            <a:ext cx="7863840" cy="594360"/>
           </a:xfrm>
           <a:prstGeom prst="rect">
             <a:avLst/>
@@ -19067,7 +17660,7 @@
               <a:buNone/>
             </a:pPr>
             <a:r>
-              <a:rPr b="0" i="0" lang="en-US" sz="2100" u="none" cap="none" strike="noStrike">
+              <a:rPr b="0" i="0" lang="en-US" sz="1900" u="none" cap="none" strike="noStrike">
                 <a:solidFill>
                   <a:srgbClr val="F6F7FA"/>
                 </a:solidFill>
@@ -19076,7 +17669,323 @@
                 <a:cs typeface="Arial"/>
                 <a:sym typeface="Arial"/>
               </a:rPr>
-              <a:t>More Rust work continues alongside C.</a:t>
+              <a:t>Rust is used in security-sensitive Android code.</a:t>
+            </a:r>
+            <a:endParaRPr/>
+          </a:p>
+        </p:txBody>
+      </p:sp>
+      <p:sp>
+        <p:nvSpPr>
+          <p:cNvPr id="211" name="Google Shape;211;p21"/>
+          <p:cNvSpPr/>
+          <p:nvPr/>
+        </p:nvSpPr>
+        <p:spPr>
+          <a:xfrm>
+            <a:off x="749808" y="3986784"/>
+            <a:ext cx="2514600" cy="731520"/>
+          </a:xfrm>
+          <a:prstGeom prst="rect">
+            <a:avLst/>
+          </a:prstGeom>
+          <a:solidFill>
+            <a:srgbClr val="1D2B3F"/>
+          </a:solidFill>
+          <a:ln>
+            <a:noFill/>
+          </a:ln>
+          <a:effectLst>
+            <a:outerShdw blurRad="40000" rotWithShape="0" dir="5400000" dist="23000">
+              <a:srgbClr val="000000">
+                <a:alpha val="34902"/>
+              </a:srgbClr>
+            </a:outerShdw>
+          </a:effectLst>
+        </p:spPr>
+        <p:txBody>
+          <a:bodyPr anchorCtr="0" anchor="ctr" bIns="45700" lIns="91425" spcFirstLastPara="1" rIns="91425" wrap="square" tIns="45700">
+            <a:noAutofit/>
+          </a:bodyPr>
+          <a:lstStyle/>
+          <a:p>
+            <a:pPr indent="0" lvl="0" marL="0" marR="0" rtl="0" algn="ctr">
+              <a:spcBef>
+                <a:spcPts val="0"/>
+              </a:spcBef>
+              <a:spcAft>
+                <a:spcPts val="0"/>
+              </a:spcAft>
+              <a:buNone/>
+            </a:pPr>
+            <a:r>
+              <a:t/>
+            </a:r>
+            <a:endParaRPr b="0" i="0" sz="1800" u="none" cap="none" strike="noStrike">
+              <a:solidFill>
+                <a:schemeClr val="dk1"/>
+              </a:solidFill>
+              <a:latin typeface="Calibri"/>
+              <a:ea typeface="Calibri"/>
+              <a:cs typeface="Calibri"/>
+              <a:sym typeface="Calibri"/>
+            </a:endParaRPr>
+          </a:p>
+        </p:txBody>
+      </p:sp>
+      <p:sp>
+        <p:nvSpPr>
+          <p:cNvPr id="212" name="Google Shape;212;p21"/>
+          <p:cNvSpPr txBox="1"/>
+          <p:nvPr/>
+        </p:nvSpPr>
+        <p:spPr>
+          <a:xfrm>
+            <a:off x="950976" y="4142232"/>
+            <a:ext cx="2194560" cy="393192"/>
+          </a:xfrm>
+          <a:prstGeom prst="rect">
+            <a:avLst/>
+          </a:prstGeom>
+          <a:noFill/>
+          <a:ln>
+            <a:noFill/>
+          </a:ln>
+        </p:spPr>
+        <p:txBody>
+          <a:bodyPr anchorCtr="0" anchor="t" bIns="0" lIns="0" spcFirstLastPara="1" rIns="0" wrap="square" tIns="0">
+            <a:spAutoFit/>
+          </a:bodyPr>
+          <a:lstStyle/>
+          <a:p>
+            <a:pPr indent="0" lvl="0" marL="0" marR="0" rtl="0" algn="l">
+              <a:spcBef>
+                <a:spcPts val="0"/>
+              </a:spcBef>
+              <a:spcAft>
+                <a:spcPts val="0"/>
+              </a:spcAft>
+              <a:buNone/>
+            </a:pPr>
+            <a:r>
+              <a:rPr b="1" i="0" lang="en-US" sz="1900" u="none" cap="none" strike="noStrike">
+                <a:solidFill>
+                  <a:srgbClr val="F08443"/>
+                </a:solidFill>
+                <a:latin typeface="Arial"/>
+                <a:ea typeface="Arial"/>
+                <a:cs typeface="Arial"/>
+                <a:sym typeface="Arial"/>
+              </a:rPr>
+              <a:t>Microsoft</a:t>
+            </a:r>
+            <a:endParaRPr/>
+          </a:p>
+        </p:txBody>
+      </p:sp>
+      <p:sp>
+        <p:nvSpPr>
+          <p:cNvPr id="213" name="Google Shape;213;p21"/>
+          <p:cNvSpPr txBox="1"/>
+          <p:nvPr/>
+        </p:nvSpPr>
+        <p:spPr>
+          <a:xfrm>
+            <a:off x="3547872" y="4105656"/>
+            <a:ext cx="7863840" cy="594360"/>
+          </a:xfrm>
+          <a:prstGeom prst="rect">
+            <a:avLst/>
+          </a:prstGeom>
+          <a:noFill/>
+          <a:ln>
+            <a:noFill/>
+          </a:ln>
+        </p:spPr>
+        <p:txBody>
+          <a:bodyPr anchorCtr="0" anchor="t" bIns="0" lIns="0" spcFirstLastPara="1" rIns="0" wrap="square" tIns="0">
+            <a:spAutoFit/>
+          </a:bodyPr>
+          <a:lstStyle/>
+          <a:p>
+            <a:pPr indent="0" lvl="0" marL="0" marR="0" rtl="0" algn="l">
+              <a:spcBef>
+                <a:spcPts val="0"/>
+              </a:spcBef>
+              <a:spcAft>
+                <a:spcPts val="0"/>
+              </a:spcAft>
+              <a:buNone/>
+            </a:pPr>
+            <a:r>
+              <a:rPr b="0" i="0" lang="en-US" sz="1900" u="none" cap="none" strike="noStrike">
+                <a:solidFill>
+                  <a:srgbClr val="F6F7FA"/>
+                </a:solidFill>
+                <a:latin typeface="Arial"/>
+                <a:ea typeface="Arial"/>
+                <a:cs typeface="Arial"/>
+                <a:sym typeface="Arial"/>
+              </a:rPr>
+              <a:t>Rust is being explored and used in some systems work.</a:t>
+            </a:r>
+            <a:endParaRPr/>
+          </a:p>
+        </p:txBody>
+      </p:sp>
+      <p:sp>
+        <p:nvSpPr>
+          <p:cNvPr id="214" name="Google Shape;214;p21"/>
+          <p:cNvSpPr/>
+          <p:nvPr/>
+        </p:nvSpPr>
+        <p:spPr>
+          <a:xfrm>
+            <a:off x="749808" y="5010912"/>
+            <a:ext cx="2514600" cy="731520"/>
+          </a:xfrm>
+          <a:prstGeom prst="rect">
+            <a:avLst/>
+          </a:prstGeom>
+          <a:solidFill>
+            <a:srgbClr val="1D2B3F"/>
+          </a:solidFill>
+          <a:ln>
+            <a:noFill/>
+          </a:ln>
+          <a:effectLst>
+            <a:outerShdw blurRad="40000" rotWithShape="0" dir="5400000" dist="23000">
+              <a:srgbClr val="000000">
+                <a:alpha val="34902"/>
+              </a:srgbClr>
+            </a:outerShdw>
+          </a:effectLst>
+        </p:spPr>
+        <p:txBody>
+          <a:bodyPr anchorCtr="0" anchor="ctr" bIns="45700" lIns="91425" spcFirstLastPara="1" rIns="91425" wrap="square" tIns="45700">
+            <a:noAutofit/>
+          </a:bodyPr>
+          <a:lstStyle/>
+          <a:p>
+            <a:pPr indent="0" lvl="0" marL="0" marR="0" rtl="0" algn="ctr">
+              <a:spcBef>
+                <a:spcPts val="0"/>
+              </a:spcBef>
+              <a:spcAft>
+                <a:spcPts val="0"/>
+              </a:spcAft>
+              <a:buNone/>
+            </a:pPr>
+            <a:r>
+              <a:t/>
+            </a:r>
+            <a:endParaRPr b="0" i="0" sz="1800" u="none" cap="none" strike="noStrike">
+              <a:solidFill>
+                <a:schemeClr val="dk1"/>
+              </a:solidFill>
+              <a:latin typeface="Calibri"/>
+              <a:ea typeface="Calibri"/>
+              <a:cs typeface="Calibri"/>
+              <a:sym typeface="Calibri"/>
+            </a:endParaRPr>
+          </a:p>
+        </p:txBody>
+      </p:sp>
+      <p:sp>
+        <p:nvSpPr>
+          <p:cNvPr id="215" name="Google Shape;215;p21"/>
+          <p:cNvSpPr txBox="1"/>
+          <p:nvPr/>
+        </p:nvSpPr>
+        <p:spPr>
+          <a:xfrm>
+            <a:off x="950976" y="5166360"/>
+            <a:ext cx="2194560" cy="393192"/>
+          </a:xfrm>
+          <a:prstGeom prst="rect">
+            <a:avLst/>
+          </a:prstGeom>
+          <a:noFill/>
+          <a:ln>
+            <a:noFill/>
+          </a:ln>
+        </p:spPr>
+        <p:txBody>
+          <a:bodyPr anchorCtr="0" anchor="t" bIns="0" lIns="0" spcFirstLastPara="1" rIns="0" wrap="square" tIns="0">
+            <a:spAutoFit/>
+          </a:bodyPr>
+          <a:lstStyle/>
+          <a:p>
+            <a:pPr indent="0" lvl="0" marL="0" marR="0" rtl="0" algn="l">
+              <a:spcBef>
+                <a:spcPts val="0"/>
+              </a:spcBef>
+              <a:spcAft>
+                <a:spcPts val="0"/>
+              </a:spcAft>
+              <a:buNone/>
+            </a:pPr>
+            <a:r>
+              <a:rPr b="1" i="0" lang="en-US" sz="1900" u="none" cap="none" strike="noStrike">
+                <a:solidFill>
+                  <a:srgbClr val="F08443"/>
+                </a:solidFill>
+                <a:latin typeface="Arial"/>
+                <a:ea typeface="Arial"/>
+                <a:cs typeface="Arial"/>
+                <a:sym typeface="Arial"/>
+              </a:rPr>
+              <a:t>AWS</a:t>
+            </a:r>
+            <a:endParaRPr/>
+          </a:p>
+        </p:txBody>
+      </p:sp>
+      <p:sp>
+        <p:nvSpPr>
+          <p:cNvPr id="216" name="Google Shape;216;p21"/>
+          <p:cNvSpPr txBox="1"/>
+          <p:nvPr/>
+        </p:nvSpPr>
+        <p:spPr>
+          <a:xfrm>
+            <a:off x="3547872" y="5129784"/>
+            <a:ext cx="7863840" cy="594360"/>
+          </a:xfrm>
+          <a:prstGeom prst="rect">
+            <a:avLst/>
+          </a:prstGeom>
+          <a:noFill/>
+          <a:ln>
+            <a:noFill/>
+          </a:ln>
+        </p:spPr>
+        <p:txBody>
+          <a:bodyPr anchorCtr="0" anchor="t" bIns="0" lIns="0" spcFirstLastPara="1" rIns="0" wrap="square" tIns="0">
+            <a:spAutoFit/>
+          </a:bodyPr>
+          <a:lstStyle/>
+          <a:p>
+            <a:pPr indent="0" lvl="0" marL="0" marR="0" rtl="0" algn="l">
+              <a:spcBef>
+                <a:spcPts val="0"/>
+              </a:spcBef>
+              <a:spcAft>
+                <a:spcPts val="0"/>
+              </a:spcAft>
+              <a:buNone/>
+            </a:pPr>
+            <a:r>
+              <a:rPr b="0" i="0" lang="en-US" sz="1900" u="none" cap="none" strike="noStrike">
+                <a:solidFill>
+                  <a:srgbClr val="F6F7FA"/>
+                </a:solidFill>
+                <a:latin typeface="Arial"/>
+                <a:ea typeface="Arial"/>
+                <a:cs typeface="Arial"/>
+                <a:sym typeface="Arial"/>
+              </a:rPr>
+              <a:t>Rust powers projects such as Firecracker.</a:t>
             </a:r>
             <a:endParaRPr/>
           </a:p>

</xml_diff>